<commit_message>
docs: deck PDF export; fix danda glyph on challenges slide, larger text on limits slide
</commit_message>
<xml_diff>
--- a/docs/Bhoomi_Kaaval_Deck.pptx
+++ b/docs/Bhoomi_Kaaval_Deck.pptx
@@ -121,18 +121,18 @@
   <p:extLst>
     <p:ext uri="{521415D9-36F7-43E2-AB2F-B90AF26B5E84}">
       <p14:sectionLst xmlns:p14="http://schemas.microsoft.com/office/powerpoint/2010/main">
-        <p14:section name="Opening" id="{8d897574-89af-c8dd-e4de-26209f018c9b}">
+        <p14:section name="Opening" id="{bad97f09-f72c-e105-c0eb-6d615e474101}">
           <p14:sldIdLst>
             <p14:sldId id="256"/>
           </p14:sldIdLst>
         </p14:section>
-        <p14:section name="Problem and solution" id="{44e0bb41-51dd-3e05-a712-cd080eaf2780}">
+        <p14:section name="Problem and solution" id="{f78e5fce-03ce-1ca1-1e77-ffc7cf5e39ed}">
           <p14:sldIdLst>
             <p14:sldId id="257"/>
             <p14:sldId id="258"/>
           </p14:sldIdLst>
         </p14:section>
-        <p14:section name="How it works" id="{62636938-db4a-ccb5-ebf9-1311856b57cd}">
+        <p14:section name="How it works" id="{e0235786-9636-3205-7338-aae91278d5df}">
           <p14:sldIdLst>
             <p14:sldId id="259"/>
             <p14:sldId id="260"/>
@@ -141,20 +141,20 @@
             <p14:sldId id="263"/>
           </p14:sldIdLst>
         </p14:section>
-        <p14:section name="Tools and Cline" id="{96c12dcb-362c-38e8-486e-59e3f68af821}">
+        <p14:section name="Tools and Cline" id="{82d37328-6b07-59a7-b333-ec86ca96b8ef}">
           <p14:sldIdLst>
             <p14:sldId id="264"/>
             <p14:sldId id="265"/>
           </p14:sldIdLst>
         </p14:section>
-        <p14:section name="Proof" id="{0aa6856a-b8b4-3059-4f89-96d13454426c}">
+        <p14:section name="Proof" id="{a93d4730-8177-9b04-6286-df9b4e8b2f09}">
           <p14:sldIdLst>
             <p14:sldId id="266"/>
             <p14:sldId id="267"/>
             <p14:sldId id="268"/>
           </p14:sldIdLst>
         </p14:section>
-        <p14:section name="Wrap-up" id="{37984d2f-da76-89d3-8710-018ad5af805d}">
+        <p14:section name="Wrap-up" id="{076b5799-5883-9838-012f-b9b12011a166}">
           <p14:sldIdLst>
             <p14:sldId id="269"/>
             <p14:sldId id="270"/>
@@ -4671,7 +4671,7 @@
                   <a:schemeClr val="tx1"/>
                 </a:solidFill>
               </a:rPr>
-              <a:t>An Aadhaar number was not masked when it ended a sentence (“.” or Hindi “।”)</a:t>
+              <a:t>An Aadhaar number was not masked when a full stop (or the Hindi danda) followed it</a:t>
             </a:r>
             <a:endParaRPr lang="en-US" sz="1400" dirty="0"/>
           </a:p>
@@ -6598,7 +6598,7 @@
         <p:spPr>
           <a:xfrm>
             <a:off x="822960" y="2194560"/>
-            <a:ext cx="4815688" cy="3657600"/>
+            <a:ext cx="4815688" cy="3749040"/>
           </a:xfrm>
           <a:prstGeom prst="rect">
             <a:avLst/>
@@ -6612,92 +6612,92 @@
           <a:p>
             <a:pPr marL="177800" indent="-177800">
               <a:spcAft>
-                <a:spcPts val="800"/>
+                <a:spcPts val="1200"/>
               </a:spcAft>
               <a:buSzPct val="100000"/>
               <a:buChar char="•"/>
             </a:pPr>
             <a:r>
-              <a:rPr lang="en-US" sz="1500" dirty="0">
+              <a:rPr lang="en-US" sz="1700" dirty="0">
                 <a:solidFill>
                   <a:schemeClr val="tx1"/>
                 </a:solidFill>
               </a:rPr>
               <a:t>Synthetic documents, one model: this shows the logic, not real-world accuracy</a:t>
             </a:r>
-            <a:endParaRPr lang="en-US" sz="1500" dirty="0"/>
+            <a:endParaRPr lang="en-US" sz="1700" dirty="0"/>
           </a:p>
           <a:p>
             <a:pPr marL="177800" indent="-177800">
               <a:spcAft>
-                <a:spcPts val="800"/>
+                <a:spcPts val="1200"/>
               </a:spcAft>
               <a:buSzPct val="100000"/>
               <a:buChar char="•"/>
             </a:pPr>
             <a:r>
-              <a:rPr lang="en-US" sz="1500" dirty="0">
+              <a:rPr lang="en-US" sz="1700" dirty="0">
                 <a:solidFill>
                   <a:schemeClr val="tx1"/>
                 </a:solidFill>
               </a:rPr>
               <a:t>English and Hindi tested; Assamese not tested</a:t>
             </a:r>
-            <a:endParaRPr lang="en-US" sz="1500" dirty="0"/>
+            <a:endParaRPr lang="en-US" sz="1700" dirty="0"/>
           </a:p>
           <a:p>
             <a:pPr marL="177800" indent="-177800">
               <a:spcAft>
-                <a:spcPts val="800"/>
+                <a:spcPts val="1200"/>
               </a:spcAft>
               <a:buSzPct val="100000"/>
               <a:buChar char="•"/>
             </a:pPr>
             <a:r>
-              <a:rPr lang="en-US" sz="1500" dirty="0">
+              <a:rPr lang="en-US" sz="1700" dirty="0">
                 <a:solidFill>
                   <a:schemeClr val="tx1"/>
                 </a:solidFill>
               </a:rPr>
               <a:t>Handwriting tested with a handwriting font, which is tidier than real writing</a:t>
             </a:r>
-            <a:endParaRPr lang="en-US" sz="1500" dirty="0"/>
+            <a:endParaRPr lang="en-US" sz="1700" dirty="0"/>
           </a:p>
           <a:p>
             <a:pPr marL="177800" indent="-177800">
               <a:spcAft>
-                <a:spcPts val="800"/>
+                <a:spcPts val="1200"/>
               </a:spcAft>
               <a:buSzPct val="100000"/>
               <a:buChar char="•"/>
             </a:pPr>
             <a:r>
-              <a:rPr lang="en-US" sz="1500" dirty="0">
+              <a:rPr lang="en-US" sz="1700" dirty="0">
                 <a:solidFill>
                   <a:schemeClr val="tx1"/>
                 </a:solidFill>
               </a:rPr>
               <a:t>Handwritten ID numbers cannot be masked automatically</a:t>
             </a:r>
-            <a:endParaRPr lang="en-US" sz="1500" dirty="0"/>
+            <a:endParaRPr lang="en-US" sz="1700" dirty="0"/>
           </a:p>
           <a:p>
             <a:pPr marL="177800" indent="-177800">
               <a:spcAft>
-                <a:spcPts val="800"/>
+                <a:spcPts val="1200"/>
               </a:spcAft>
               <a:buSzPct val="100000"/>
               <a:buChar char="•"/>
             </a:pPr>
             <a:r>
-              <a:rPr lang="en-US" sz="1500" dirty="0">
+              <a:rPr lang="en-US" sz="1700" dirty="0">
                 <a:solidFill>
                   <a:schemeClr val="tx1"/>
                 </a:solidFill>
               </a:rPr>
               <a:t>A deed-only view cannot see inheritance, mutations or litigation</a:t>
             </a:r>
-            <a:endParaRPr lang="en-US" sz="1500" dirty="0"/>
+            <a:endParaRPr lang="en-US" sz="1700" dirty="0"/>
           </a:p>
         </p:txBody>
       </p:sp>
@@ -6780,7 +6780,7 @@
         <p:spPr>
           <a:xfrm>
             <a:off x="6553048" y="2194560"/>
-            <a:ext cx="4815688" cy="3657600"/>
+            <a:ext cx="4815688" cy="3749040"/>
           </a:xfrm>
           <a:prstGeom prst="rect">
             <a:avLst/>
@@ -6794,92 +6794,92 @@
           <a:p>
             <a:pPr marL="177800" indent="-177800">
               <a:spcAft>
-                <a:spcPts val="800"/>
+                <a:spcPts val="1200"/>
               </a:spcAft>
               <a:buSzPct val="100000"/>
               <a:buChar char="•"/>
             </a:pPr>
             <a:r>
-              <a:rPr lang="en-US" sz="1500" dirty="0">
+              <a:rPr lang="en-US" sz="1700" dirty="0">
                 <a:solidFill>
                   <a:schemeClr val="tx1"/>
                 </a:solidFill>
               </a:rPr>
               <a:t>Pilot with one Sub-Registrar office on a sandbox registry feed</a:t>
             </a:r>
-            <a:endParaRPr lang="en-US" sz="1500" dirty="0"/>
+            <a:endParaRPr lang="en-US" sz="1700" dirty="0"/>
           </a:p>
           <a:p>
             <a:pPr marL="177800" indent="-177800">
               <a:spcAft>
-                <a:spcPts val="800"/>
+                <a:spcPts val="1200"/>
               </a:spcAft>
               <a:buSzPct val="100000"/>
               <a:buChar char="•"/>
             </a:pPr>
             <a:r>
-              <a:rPr lang="en-US" sz="1500" dirty="0">
+              <a:rPr lang="en-US" sz="1700" dirty="0">
                 <a:solidFill>
                   <a:schemeClr val="tx1"/>
                 </a:solidFill>
               </a:rPr>
               <a:t>Self-hosted Indic vision model, so documents never leave the department</a:t>
             </a:r>
-            <a:endParaRPr lang="en-US" sz="1500" dirty="0"/>
+            <a:endParaRPr lang="en-US" sz="1700" dirty="0"/>
           </a:p>
           <a:p>
             <a:pPr marL="177800" indent="-177800">
               <a:spcAft>
-                <a:spcPts val="800"/>
+                <a:spcPts val="1200"/>
               </a:spcAft>
               <a:buSzPct val="100000"/>
               <a:buChar char="•"/>
             </a:pPr>
             <a:r>
-              <a:rPr lang="en-US" sz="1500" dirty="0">
+              <a:rPr lang="en-US" sz="1700" dirty="0">
                 <a:solidFill>
                   <a:schemeClr val="tx1"/>
                 </a:solidFill>
               </a:rPr>
               <a:t>State-specific rule packs and an Indic handwriting test set from consented specimens</a:t>
             </a:r>
-            <a:endParaRPr lang="en-US" sz="1500" dirty="0"/>
+            <a:endParaRPr lang="en-US" sz="1700" dirty="0"/>
           </a:p>
           <a:p>
             <a:pPr marL="177800" indent="-177800">
               <a:spcAft>
-                <a:spcPts val="800"/>
+                <a:spcPts val="1200"/>
               </a:spcAft>
               <a:buSzPct val="100000"/>
               <a:buChar char="•"/>
             </a:pPr>
             <a:r>
-              <a:rPr lang="en-US" sz="1500" dirty="0">
+              <a:rPr lang="en-US" sz="1700" dirty="0">
                 <a:solidFill>
                   <a:schemeClr val="tx1"/>
                 </a:solidFill>
               </a:rPr>
               <a:t>Transliteration-aware name matching across scripts</a:t>
             </a:r>
-            <a:endParaRPr lang="en-US" sz="1500" dirty="0"/>
+            <a:endParaRPr lang="en-US" sz="1700" dirty="0"/>
           </a:p>
           <a:p>
             <a:pPr marL="177800" indent="-177800">
               <a:spcAft>
-                <a:spcPts val="800"/>
+                <a:spcPts val="1200"/>
               </a:spcAft>
               <a:buSzPct val="100000"/>
               <a:buChar char="•"/>
             </a:pPr>
             <a:r>
-              <a:rPr lang="en-US" sz="1500" dirty="0">
+              <a:rPr lang="en-US" sz="1700" dirty="0">
                 <a:solidFill>
                   <a:schemeClr val="tx1"/>
                 </a:solidFill>
               </a:rPr>
               <a:t>A Cline-powered assistant that answers “why was this flagged?” from the evidence</a:t>
             </a:r>
-            <a:endParaRPr lang="en-US" sz="1500" dirty="0"/>
+            <a:endParaRPr lang="en-US" sz="1700" dirty="0"/>
           </a:p>
         </p:txBody>
       </p:sp>

</xml_diff>

<commit_message>
docs: visual challenges and limits/roadmap slides in the deck
</commit_message>
<xml_diff>
--- a/docs/Bhoomi_Kaaval_Deck.pptx
+++ b/docs/Bhoomi_Kaaval_Deck.pptx
@@ -122,18 +122,18 @@
   <p:extLst>
     <p:ext uri="{521415D9-36F7-43E2-AB2F-B90AF26B5E84}">
       <p14:sectionLst xmlns:p14="http://schemas.microsoft.com/office/powerpoint/2010/main">
-        <p14:section name="Opening" id="{70c68c9b-65d1-592a-c912-313cccdc4302}">
+        <p14:section name="Opening" id="{a49cc097-f221-494d-e241-100d08fbf533}">
           <p14:sldIdLst>
             <p14:sldId id="256"/>
           </p14:sldIdLst>
         </p14:section>
-        <p14:section name="Problem and solution" id="{782a356c-72b0-46ad-c7a1-a309ef2cb65a}">
+        <p14:section name="Problem and solution" id="{f648e6f2-9110-fd19-1718-1b6234c09db4}">
           <p14:sldIdLst>
             <p14:sldId id="257"/>
             <p14:sldId id="258"/>
           </p14:sldIdLst>
         </p14:section>
-        <p14:section name="How it works" id="{fdd06512-c318-9639-ff7b-9d945ba90245}">
+        <p14:section name="How it works" id="{7b8efe62-fecc-a114-001c-0407b1102044}">
           <p14:sldIdLst>
             <p14:sldId id="259"/>
             <p14:sldId id="260"/>
@@ -143,20 +143,20 @@
             <p14:sldId id="264"/>
           </p14:sldIdLst>
         </p14:section>
-        <p14:section name="Tools and Cline" id="{6b973eeb-29af-7791-46e0-996c9b5f788b}">
+        <p14:section name="Tools and Cline" id="{239739d6-7e8f-0d4a-b561-5f104806adb9}">
           <p14:sldIdLst>
             <p14:sldId id="265"/>
             <p14:sldId id="266"/>
           </p14:sldIdLst>
         </p14:section>
-        <p14:section name="Proof" id="{3af85e37-20d0-d060-f7b0-468049cf5e2e}">
+        <p14:section name="Proof" id="{6bcf06a5-f34d-c760-0f84-4efa2019f401}">
           <p14:sldIdLst>
             <p14:sldId id="267"/>
             <p14:sldId id="268"/>
             <p14:sldId id="269"/>
           </p14:sldIdLst>
         </p14:section>
-        <p14:section name="Wrap-up" id="{de1d9a7d-1e80-5578-01b9-ed3825f37942}">
+        <p14:section name="Wrap-up" id="{6c0e32eb-7399-2ab2-acac-b1a9d49b8efb}">
           <p14:sldIdLst>
             <p14:sldId id="270"/>
             <p14:sldId id="271"/>
@@ -1240,7 +1240,7 @@
           <a:p>
             <a:r>
               <a:rPr lang="en-US" dirty="0"/>
-              <a:t>Real documents found real bugs that clean test files never showed. The redaction one matters most: a privacy guarantee is only as good as the formats it has been tested on, so each fix has a regression test.</a:t>
+              <a:t>Real documents found real bugs that clean test files never showed. The redaction one matters most: a privacy guarantee is only as good as the formats it has been tested on.</a:t>
             </a:r>
             <a:endParaRPr lang="en-US" dirty="0"/>
           </a:p>
@@ -1416,7 +1416,7 @@
           <a:p>
             <a:r>
               <a:rPr lang="en-US" dirty="0"/>
-              <a:t>We would rather show our limits than overclaim. The next step that matters most is a pilot with a real registry feed and a self-hosted model.</a:t>
+              <a:t>Left: exactly what we have and have not tested, so nothing is overclaimed. Right: the roadmap, with the pilot and a self-hosted model first, because those matter most for real use.</a:t>
             </a:r>
             <a:endParaRPr lang="en-US" dirty="0"/>
           </a:p>
@@ -5724,8 +5724,8 @@
         </p:nvSpPr>
         <p:spPr>
           <a:xfrm>
-            <a:off x="548640" y="1508760"/>
-            <a:ext cx="6035040" cy="320040"/>
+            <a:off x="548640" y="1481328"/>
+            <a:ext cx="3749040" cy="457200"/>
           </a:xfrm>
           <a:prstGeom prst="rect">
             <a:avLst/>
@@ -5734,21 +5734,21 @@
           <a:ln/>
         </p:spPr>
         <p:txBody>
-          <a:bodyPr wrap="square" lIns="0" tIns="0" rIns="0" bIns="0" rtlCol="0" anchor="t"/>
+          <a:bodyPr wrap="square" lIns="0" tIns="0" rIns="0" bIns="0" rtlCol="0" anchor="ctr"/>
           <a:lstStyle/>
           <a:p>
             <a:pPr indent="0" marL="0">
               <a:buNone/>
             </a:pPr>
             <a:r>
-              <a:rPr lang="en-US" sz="1400" b="1" dirty="0">
-                <a:solidFill>
-                  <a:srgbClr val="5B7276"/>
-                </a:solidFill>
-              </a:rPr>
-              <a:t>What went wrong</a:t>
-            </a:r>
-            <a:endParaRPr lang="en-US" sz="1400" dirty="0"/>
+              <a:rPr lang="en-US" sz="1500" b="1" dirty="0">
+                <a:solidFill>
+                  <a:schemeClr val="tx2"/>
+                </a:solidFill>
+              </a:rPr>
+              <a:t>5 problems found with real inputs, all fixed:</a:t>
+            </a:r>
+            <a:endParaRPr lang="en-US" sz="1500" dirty="0"/>
           </a:p>
         </p:txBody>
       </p:sp>
@@ -5760,48 +5760,172 @@
         </p:nvSpPr>
         <p:spPr>
           <a:xfrm>
-            <a:off x="7040880" y="1508760"/>
-            <a:ext cx="4602175" cy="320040"/>
-          </a:xfrm>
-          <a:prstGeom prst="rect">
-            <a:avLst/>
-          </a:prstGeom>
-          <a:noFill/>
-          <a:ln/>
-        </p:spPr>
-        <p:txBody>
-          <a:bodyPr wrap="square" lIns="0" tIns="0" rIns="0" bIns="0" rtlCol="0" anchor="t"/>
-          <a:lstStyle/>
-          <a:p>
-            <a:pPr indent="0" marL="0">
-              <a:buNone/>
-            </a:pPr>
-            <a:r>
-              <a:rPr lang="en-US" sz="1400" b="1" dirty="0">
-                <a:solidFill>
-                  <a:srgbClr val="5B7276"/>
-                </a:solidFill>
-              </a:rPr>
-              <a:t>What we did</a:t>
-            </a:r>
-            <a:endParaRPr lang="en-US" sz="1400" dirty="0"/>
-          </a:p>
-        </p:txBody>
-      </p:sp>
-      <p:sp>
-        <p:nvSpPr>
-          <p:cNvPr id="5" name="Shape 3"/>
-          <p:cNvSpPr/>
-          <p:nvPr/>
-        </p:nvSpPr>
-        <p:spPr>
-          <a:xfrm>
-            <a:off x="548640" y="1920240"/>
-            <a:ext cx="6035040" cy="786384"/>
+            <a:off x="4389120" y="1481328"/>
+            <a:ext cx="1691640" cy="457200"/>
           </a:xfrm>
           <a:prstGeom prst="roundRect">
             <a:avLst>
-              <a:gd name="adj" fmla="val 13953"/>
+              <a:gd name="adj" fmla="val 24000"/>
+            </a:avLst>
+          </a:prstGeom>
+          <a:solidFill>
+            <a:schemeClr val="accent3"/>
+          </a:solidFill>
+          <a:ln/>
+        </p:spPr>
+        <p:txBody>
+          <a:bodyPr wrap="square" lIns="0" tIns="0" rIns="0" bIns="0" rtlCol="0" anchor="ctr"/>
+          <a:lstStyle/>
+          <a:p>
+            <a:pPr algn="ctr" indent="0" marL="0">
+              <a:buNone/>
+            </a:pPr>
+            <a:r>
+              <a:rPr lang="en-US" sz="1400" b="1" dirty="0">
+                <a:solidFill>
+                  <a:schemeClr val="bg1"/>
+                </a:solidFill>
+              </a:rPr>
+              <a:t>Privacy  ·  1</a:t>
+            </a:r>
+            <a:endParaRPr lang="en-US" sz="1400" dirty="0"/>
+          </a:p>
+        </p:txBody>
+      </p:sp>
+      <p:sp>
+        <p:nvSpPr>
+          <p:cNvPr id="5" name="Text 3"/>
+          <p:cNvSpPr txBox="1"/>
+          <p:nvPr/>
+        </p:nvSpPr>
+        <p:spPr>
+          <a:xfrm>
+            <a:off x="6172200" y="1481328"/>
+            <a:ext cx="1691640" cy="457200"/>
+          </a:xfrm>
+          <a:prstGeom prst="roundRect">
+            <a:avLst>
+              <a:gd name="adj" fmla="val 24000"/>
+            </a:avLst>
+          </a:prstGeom>
+          <a:solidFill>
+            <a:schemeClr val="accent4"/>
+          </a:solidFill>
+          <a:ln/>
+        </p:spPr>
+        <p:txBody>
+          <a:bodyPr wrap="square" lIns="0" tIns="0" rIns="0" bIns="0" rtlCol="0" anchor="ctr"/>
+          <a:lstStyle/>
+          <a:p>
+            <a:pPr algn="ctr" indent="0" marL="0">
+              <a:buNone/>
+            </a:pPr>
+            <a:r>
+              <a:rPr lang="en-US" sz="1400" b="1" dirty="0">
+                <a:solidFill>
+                  <a:schemeClr val="bg1"/>
+                </a:solidFill>
+              </a:rPr>
+              <a:t>Reliability  ·  2</a:t>
+            </a:r>
+            <a:endParaRPr lang="en-US" sz="1400" dirty="0"/>
+          </a:p>
+        </p:txBody>
+      </p:sp>
+      <p:sp>
+        <p:nvSpPr>
+          <p:cNvPr id="6" name="Text 4"/>
+          <p:cNvSpPr txBox="1"/>
+          <p:nvPr/>
+        </p:nvSpPr>
+        <p:spPr>
+          <a:xfrm>
+            <a:off x="7955280" y="1481328"/>
+            <a:ext cx="1691640" cy="457200"/>
+          </a:xfrm>
+          <a:prstGeom prst="roundRect">
+            <a:avLst>
+              <a:gd name="adj" fmla="val 24000"/>
+            </a:avLst>
+          </a:prstGeom>
+          <a:solidFill>
+            <a:schemeClr val="accent5"/>
+          </a:solidFill>
+          <a:ln/>
+        </p:spPr>
+        <p:txBody>
+          <a:bodyPr wrap="square" lIns="0" tIns="0" rIns="0" bIns="0" rtlCol="0" anchor="ctr"/>
+          <a:lstStyle/>
+          <a:p>
+            <a:pPr algn="ctr" indent="0" marL="0">
+              <a:buNone/>
+            </a:pPr>
+            <a:r>
+              <a:rPr lang="en-US" sz="1400" b="1" dirty="0">
+                <a:solidFill>
+                  <a:schemeClr val="bg1"/>
+                </a:solidFill>
+              </a:rPr>
+              <a:t>Integration  ·  1</a:t>
+            </a:r>
+            <a:endParaRPr lang="en-US" sz="1400" dirty="0"/>
+          </a:p>
+        </p:txBody>
+      </p:sp>
+      <p:sp>
+        <p:nvSpPr>
+          <p:cNvPr id="7" name="Text 5"/>
+          <p:cNvSpPr txBox="1"/>
+          <p:nvPr/>
+        </p:nvSpPr>
+        <p:spPr>
+          <a:xfrm>
+            <a:off x="9738360" y="1481328"/>
+            <a:ext cx="1691640" cy="457200"/>
+          </a:xfrm>
+          <a:prstGeom prst="roundRect">
+            <a:avLst>
+              <a:gd name="adj" fmla="val 24000"/>
+            </a:avLst>
+          </a:prstGeom>
+          <a:solidFill>
+            <a:schemeClr val="accent1"/>
+          </a:solidFill>
+          <a:ln/>
+        </p:spPr>
+        <p:txBody>
+          <a:bodyPr wrap="square" lIns="0" tIns="0" rIns="0" bIns="0" rtlCol="0" anchor="ctr"/>
+          <a:lstStyle/>
+          <a:p>
+            <a:pPr algn="ctr" indent="0" marL="0">
+              <a:buNone/>
+            </a:pPr>
+            <a:r>
+              <a:rPr lang="en-US" sz="1400" b="1" dirty="0">
+                <a:solidFill>
+                  <a:schemeClr val="bg1"/>
+                </a:solidFill>
+              </a:rPr>
+              <a:t>Cost and quota  ·  1</a:t>
+            </a:r>
+            <a:endParaRPr lang="en-US" sz="1400" dirty="0"/>
+          </a:p>
+        </p:txBody>
+      </p:sp>
+      <p:sp>
+        <p:nvSpPr>
+          <p:cNvPr id="8" name="Shape 6"/>
+          <p:cNvSpPr/>
+          <p:nvPr/>
+        </p:nvSpPr>
+        <p:spPr>
+          <a:xfrm>
+            <a:off x="548640" y="2148840"/>
+            <a:ext cx="6309360" cy="694944"/>
+          </a:xfrm>
+          <a:prstGeom prst="roundRect">
+            <a:avLst>
+              <a:gd name="adj" fmla="val 15789"/>
             </a:avLst>
           </a:prstGeom>
           <a:solidFill>
@@ -5824,14 +5948,63 @@
       </p:sp>
       <p:sp>
         <p:nvSpPr>
-          <p:cNvPr id="6" name="Text 4"/>
+          <p:cNvPr id="9" name="Shape 7"/>
+          <p:cNvSpPr/>
+          <p:nvPr/>
+        </p:nvSpPr>
+        <p:spPr>
+          <a:xfrm>
+            <a:off x="685800" y="2249424"/>
+            <a:ext cx="457200" cy="457200"/>
+          </a:xfrm>
+          <a:prstGeom prst="ellipse">
+            <a:avLst/>
+          </a:prstGeom>
+          <a:solidFill>
+            <a:schemeClr val="accent3"/>
+          </a:solidFill>
+          <a:ln w="12700">
+            <a:solidFill>
+              <a:schemeClr val="accent3"/>
+            </a:solidFill>
+            <a:prstDash val="solid"/>
+          </a:ln>
+        </p:spPr>
+      </p:sp>
+      <p:pic>
+        <p:nvPicPr>
+          <p:cNvPr id="10" name="Image 0" descr="ShieldHalved">    </p:cNvPr>
+          <p:cNvPicPr>
+            <a:picLocks noChangeAspect="1"/>
+          </p:cNvPicPr>
+          <p:nvPr/>
+        </p:nvPicPr>
+        <p:blipFill>
+          <a:blip r:embed="rId1"/>
+          <a:stretch>
+            <a:fillRect/>
+          </a:stretch>
+        </p:blipFill>
+        <p:spPr>
+          <a:xfrm>
+            <a:off x="800100" y="2363724"/>
+            <a:ext cx="228600" cy="228600"/>
+          </a:xfrm>
+          <a:prstGeom prst="rect">
+            <a:avLst/>
+          </a:prstGeom>
+        </p:spPr>
+      </p:pic>
+      <p:sp>
+        <p:nvSpPr>
+          <p:cNvPr id="11" name="Text 8"/>
           <p:cNvSpPr txBox="1"/>
           <p:nvPr/>
         </p:nvSpPr>
         <p:spPr>
           <a:xfrm>
-            <a:off x="731520" y="1920240"/>
-            <a:ext cx="5669280" cy="786384"/>
+            <a:off x="1280160" y="2148840"/>
+            <a:ext cx="5440680" cy="694944"/>
           </a:xfrm>
           <a:prstGeom prst="rect">
             <a:avLst/>
@@ -5860,13 +6033,13 @@
       </p:sp>
       <p:sp>
         <p:nvSpPr>
-          <p:cNvPr id="7" name="Shape 5"/>
+          <p:cNvPr id="12" name="Shape 9"/>
           <p:cNvSpPr/>
           <p:nvPr/>
         </p:nvSpPr>
         <p:spPr>
           <a:xfrm>
-            <a:off x="6675120" y="2194560"/>
+            <a:off x="6922008" y="2377440"/>
             <a:ext cx="274320" cy="237744"/>
           </a:xfrm>
           <a:prstGeom prst="rightArrow">
@@ -5885,18 +6058,18 @@
       </p:sp>
       <p:sp>
         <p:nvSpPr>
-          <p:cNvPr id="8" name="Shape 6"/>
+          <p:cNvPr id="13" name="Shape 10"/>
           <p:cNvSpPr/>
           <p:nvPr/>
         </p:nvSpPr>
         <p:spPr>
           <a:xfrm>
-            <a:off x="7040880" y="1920240"/>
-            <a:ext cx="4602175" cy="786384"/>
+            <a:off x="7269480" y="2148840"/>
+            <a:ext cx="4373575" cy="694944"/>
           </a:xfrm>
           <a:prstGeom prst="roundRect">
             <a:avLst>
-              <a:gd name="adj" fmla="val 13953"/>
+              <a:gd name="adj" fmla="val 15789"/>
             </a:avLst>
           </a:prstGeom>
           <a:solidFill>
@@ -5912,14 +6085,63 @@
       </p:sp>
       <p:sp>
         <p:nvSpPr>
-          <p:cNvPr id="9" name="Text 7"/>
+          <p:cNvPr id="14" name="Shape 11"/>
+          <p:cNvSpPr/>
+          <p:nvPr/>
+        </p:nvSpPr>
+        <p:spPr>
+          <a:xfrm>
+            <a:off x="7406640" y="2276856"/>
+            <a:ext cx="402336" cy="402336"/>
+          </a:xfrm>
+          <a:prstGeom prst="ellipse">
+            <a:avLst/>
+          </a:prstGeom>
+          <a:solidFill>
+            <a:schemeClr val="accent6"/>
+          </a:solidFill>
+          <a:ln w="12700">
+            <a:solidFill>
+              <a:schemeClr val="accent6"/>
+            </a:solidFill>
+            <a:prstDash val="solid"/>
+          </a:ln>
+        </p:spPr>
+      </p:sp>
+      <p:pic>
+        <p:nvPicPr>
+          <p:cNvPr id="15" name="Image 1" descr="CircleCheck">    </p:cNvPr>
+          <p:cNvPicPr>
+            <a:picLocks noChangeAspect="1"/>
+          </p:cNvPicPr>
+          <p:nvPr/>
+        </p:nvPicPr>
+        <p:blipFill>
+          <a:blip r:embed="rId2"/>
+          <a:stretch>
+            <a:fillRect/>
+          </a:stretch>
+        </p:blipFill>
+        <p:spPr>
+          <a:xfrm>
+            <a:off x="7507224" y="2377440"/>
+            <a:ext cx="201168" cy="201168"/>
+          </a:xfrm>
+          <a:prstGeom prst="rect">
+            <a:avLst/>
+          </a:prstGeom>
+        </p:spPr>
+      </p:pic>
+      <p:sp>
+        <p:nvSpPr>
+          <p:cNvPr id="16" name="Text 12"/>
           <p:cNvSpPr txBox="1"/>
           <p:nvPr/>
         </p:nvSpPr>
         <p:spPr>
           <a:xfrm>
-            <a:off x="7223760" y="1920240"/>
-            <a:ext cx="4236415" cy="786384"/>
+            <a:off x="7927848" y="2148840"/>
+            <a:ext cx="3596335" cy="694944"/>
           </a:xfrm>
           <a:prstGeom prst="rect">
             <a:avLst/>
@@ -5948,18 +6170,18 @@
       </p:sp>
       <p:sp>
         <p:nvSpPr>
-          <p:cNvPr id="10" name="Shape 8"/>
+          <p:cNvPr id="17" name="Shape 13"/>
           <p:cNvSpPr/>
           <p:nvPr/>
         </p:nvSpPr>
         <p:spPr>
           <a:xfrm>
-            <a:off x="548640" y="2816352"/>
-            <a:ext cx="6035040" cy="786384"/>
+            <a:off x="548640" y="2953512"/>
+            <a:ext cx="6309360" cy="694944"/>
           </a:xfrm>
           <a:prstGeom prst="roundRect">
             <a:avLst>
-              <a:gd name="adj" fmla="val 13953"/>
+              <a:gd name="adj" fmla="val 15789"/>
             </a:avLst>
           </a:prstGeom>
           <a:solidFill>
@@ -5982,14 +6204,63 @@
       </p:sp>
       <p:sp>
         <p:nvSpPr>
-          <p:cNvPr id="11" name="Text 9"/>
+          <p:cNvPr id="18" name="Shape 14"/>
+          <p:cNvSpPr/>
+          <p:nvPr/>
+        </p:nvSpPr>
+        <p:spPr>
+          <a:xfrm>
+            <a:off x="685800" y="3054096"/>
+            <a:ext cx="457200" cy="457200"/>
+          </a:xfrm>
+          <a:prstGeom prst="ellipse">
+            <a:avLst/>
+          </a:prstGeom>
+          <a:solidFill>
+            <a:schemeClr val="accent4"/>
+          </a:solidFill>
+          <a:ln w="12700">
+            <a:solidFill>
+              <a:schemeClr val="accent4"/>
+            </a:solidFill>
+            <a:prstDash val="solid"/>
+          </a:ln>
+        </p:spPr>
+      </p:sp>
+      <p:pic>
+        <p:nvPicPr>
+          <p:cNvPr id="19" name="Image 2" descr="Brain">    </p:cNvPr>
+          <p:cNvPicPr>
+            <a:picLocks noChangeAspect="1"/>
+          </p:cNvPicPr>
+          <p:nvPr/>
+        </p:nvPicPr>
+        <p:blipFill>
+          <a:blip r:embed="rId3"/>
+          <a:stretch>
+            <a:fillRect/>
+          </a:stretch>
+        </p:blipFill>
+        <p:spPr>
+          <a:xfrm>
+            <a:off x="800100" y="3168396"/>
+            <a:ext cx="228600" cy="228600"/>
+          </a:xfrm>
+          <a:prstGeom prst="rect">
+            <a:avLst/>
+          </a:prstGeom>
+        </p:spPr>
+      </p:pic>
+      <p:sp>
+        <p:nvSpPr>
+          <p:cNvPr id="20" name="Text 15"/>
           <p:cNvSpPr txBox="1"/>
           <p:nvPr/>
         </p:nvSpPr>
         <p:spPr>
           <a:xfrm>
-            <a:off x="731520" y="2816352"/>
-            <a:ext cx="5669280" cy="786384"/>
+            <a:off x="1280160" y="2953512"/>
+            <a:ext cx="5440680" cy="694944"/>
           </a:xfrm>
           <a:prstGeom prst="rect">
             <a:avLst/>
@@ -6018,13 +6289,13 @@
       </p:sp>
       <p:sp>
         <p:nvSpPr>
-          <p:cNvPr id="12" name="Shape 10"/>
+          <p:cNvPr id="21" name="Shape 16"/>
           <p:cNvSpPr/>
           <p:nvPr/>
         </p:nvSpPr>
         <p:spPr>
           <a:xfrm>
-            <a:off x="6675120" y="3090672"/>
+            <a:off x="6922008" y="3182112"/>
             <a:ext cx="274320" cy="237744"/>
           </a:xfrm>
           <a:prstGeom prst="rightArrow">
@@ -6043,18 +6314,18 @@
       </p:sp>
       <p:sp>
         <p:nvSpPr>
-          <p:cNvPr id="13" name="Shape 11"/>
+          <p:cNvPr id="22" name="Shape 17"/>
           <p:cNvSpPr/>
           <p:nvPr/>
         </p:nvSpPr>
         <p:spPr>
           <a:xfrm>
-            <a:off x="7040880" y="2816352"/>
-            <a:ext cx="4602175" cy="786384"/>
+            <a:off x="7269480" y="2953512"/>
+            <a:ext cx="4373575" cy="694944"/>
           </a:xfrm>
           <a:prstGeom prst="roundRect">
             <a:avLst>
-              <a:gd name="adj" fmla="val 13953"/>
+              <a:gd name="adj" fmla="val 15789"/>
             </a:avLst>
           </a:prstGeom>
           <a:solidFill>
@@ -6070,14 +6341,63 @@
       </p:sp>
       <p:sp>
         <p:nvSpPr>
-          <p:cNvPr id="14" name="Text 12"/>
+          <p:cNvPr id="23" name="Shape 18"/>
+          <p:cNvSpPr/>
+          <p:nvPr/>
+        </p:nvSpPr>
+        <p:spPr>
+          <a:xfrm>
+            <a:off x="7406640" y="3081528"/>
+            <a:ext cx="402336" cy="402336"/>
+          </a:xfrm>
+          <a:prstGeom prst="ellipse">
+            <a:avLst/>
+          </a:prstGeom>
+          <a:solidFill>
+            <a:schemeClr val="accent6"/>
+          </a:solidFill>
+          <a:ln w="12700">
+            <a:solidFill>
+              <a:schemeClr val="accent6"/>
+            </a:solidFill>
+            <a:prstDash val="solid"/>
+          </a:ln>
+        </p:spPr>
+      </p:sp>
+      <p:pic>
+        <p:nvPicPr>
+          <p:cNvPr id="24" name="Image 3" descr="CircleCheck">    </p:cNvPr>
+          <p:cNvPicPr>
+            <a:picLocks noChangeAspect="1"/>
+          </p:cNvPicPr>
+          <p:nvPr/>
+        </p:nvPicPr>
+        <p:blipFill>
+          <a:blip r:embed="rId4"/>
+          <a:stretch>
+            <a:fillRect/>
+          </a:stretch>
+        </p:blipFill>
+        <p:spPr>
+          <a:xfrm>
+            <a:off x="7507224" y="3182112"/>
+            <a:ext cx="201168" cy="201168"/>
+          </a:xfrm>
+          <a:prstGeom prst="rect">
+            <a:avLst/>
+          </a:prstGeom>
+        </p:spPr>
+      </p:pic>
+      <p:sp>
+        <p:nvSpPr>
+          <p:cNvPr id="25" name="Text 19"/>
           <p:cNvSpPr txBox="1"/>
           <p:nvPr/>
         </p:nvSpPr>
         <p:spPr>
           <a:xfrm>
-            <a:off x="7223760" y="2816352"/>
-            <a:ext cx="4236415" cy="786384"/>
+            <a:off x="7927848" y="2953512"/>
+            <a:ext cx="3596335" cy="694944"/>
           </a:xfrm>
           <a:prstGeom prst="rect">
             <a:avLst/>
@@ -6106,18 +6426,18 @@
       </p:sp>
       <p:sp>
         <p:nvSpPr>
-          <p:cNvPr id="15" name="Shape 13"/>
+          <p:cNvPr id="26" name="Shape 20"/>
           <p:cNvSpPr/>
           <p:nvPr/>
         </p:nvSpPr>
         <p:spPr>
           <a:xfrm>
-            <a:off x="548640" y="3712464"/>
-            <a:ext cx="6035040" cy="786384"/>
+            <a:off x="548640" y="3758184"/>
+            <a:ext cx="6309360" cy="694944"/>
           </a:xfrm>
           <a:prstGeom prst="roundRect">
             <a:avLst>
-              <a:gd name="adj" fmla="val 13953"/>
+              <a:gd name="adj" fmla="val 15789"/>
             </a:avLst>
           </a:prstGeom>
           <a:solidFill>
@@ -6140,14 +6460,63 @@
       </p:sp>
       <p:sp>
         <p:nvSpPr>
-          <p:cNvPr id="16" name="Text 14"/>
+          <p:cNvPr id="27" name="Shape 21"/>
+          <p:cNvSpPr/>
+          <p:nvPr/>
+        </p:nvSpPr>
+        <p:spPr>
+          <a:xfrm>
+            <a:off x="685800" y="3858768"/>
+            <a:ext cx="457200" cy="457200"/>
+          </a:xfrm>
+          <a:prstGeom prst="ellipse">
+            <a:avLst/>
+          </a:prstGeom>
+          <a:solidFill>
+            <a:schemeClr val="accent4"/>
+          </a:solidFill>
+          <a:ln w="12700">
+            <a:solidFill>
+              <a:schemeClr val="accent4"/>
+            </a:solidFill>
+            <a:prstDash val="solid"/>
+          </a:ln>
+        </p:spPr>
+      </p:sp>
+      <p:pic>
+        <p:nvPicPr>
+          <p:cNvPr id="28" name="Image 4" descr="Repeat">    </p:cNvPr>
+          <p:cNvPicPr>
+            <a:picLocks noChangeAspect="1"/>
+          </p:cNvPicPr>
+          <p:nvPr/>
+        </p:nvPicPr>
+        <p:blipFill>
+          <a:blip r:embed="rId5"/>
+          <a:stretch>
+            <a:fillRect/>
+          </a:stretch>
+        </p:blipFill>
+        <p:spPr>
+          <a:xfrm>
+            <a:off x="800100" y="3973068"/>
+            <a:ext cx="228600" cy="228600"/>
+          </a:xfrm>
+          <a:prstGeom prst="rect">
+            <a:avLst/>
+          </a:prstGeom>
+        </p:spPr>
+      </p:pic>
+      <p:sp>
+        <p:nvSpPr>
+          <p:cNvPr id="29" name="Text 22"/>
           <p:cNvSpPr txBox="1"/>
           <p:nvPr/>
         </p:nvSpPr>
         <p:spPr>
           <a:xfrm>
-            <a:off x="731520" y="3712464"/>
-            <a:ext cx="5669280" cy="786384"/>
+            <a:off x="1280160" y="3758184"/>
+            <a:ext cx="5440680" cy="694944"/>
           </a:xfrm>
           <a:prstGeom prst="rect">
             <a:avLst/>
@@ -6176,13 +6545,13 @@
       </p:sp>
       <p:sp>
         <p:nvSpPr>
-          <p:cNvPr id="17" name="Shape 15"/>
+          <p:cNvPr id="30" name="Shape 23"/>
           <p:cNvSpPr/>
           <p:nvPr/>
         </p:nvSpPr>
         <p:spPr>
           <a:xfrm>
-            <a:off x="6675120" y="3986784"/>
+            <a:off x="6922008" y="3986784"/>
             <a:ext cx="274320" cy="237744"/>
           </a:xfrm>
           <a:prstGeom prst="rightArrow">
@@ -6201,18 +6570,18 @@
       </p:sp>
       <p:sp>
         <p:nvSpPr>
-          <p:cNvPr id="18" name="Shape 16"/>
+          <p:cNvPr id="31" name="Shape 24"/>
           <p:cNvSpPr/>
           <p:nvPr/>
         </p:nvSpPr>
         <p:spPr>
           <a:xfrm>
-            <a:off x="7040880" y="3712464"/>
-            <a:ext cx="4602175" cy="786384"/>
+            <a:off x="7269480" y="3758184"/>
+            <a:ext cx="4373575" cy="694944"/>
           </a:xfrm>
           <a:prstGeom prst="roundRect">
             <a:avLst>
-              <a:gd name="adj" fmla="val 13953"/>
+              <a:gd name="adj" fmla="val 15789"/>
             </a:avLst>
           </a:prstGeom>
           <a:solidFill>
@@ -6228,14 +6597,63 @@
       </p:sp>
       <p:sp>
         <p:nvSpPr>
-          <p:cNvPr id="19" name="Text 17"/>
+          <p:cNvPr id="32" name="Shape 25"/>
+          <p:cNvSpPr/>
+          <p:nvPr/>
+        </p:nvSpPr>
+        <p:spPr>
+          <a:xfrm>
+            <a:off x="7406640" y="3886200"/>
+            <a:ext cx="402336" cy="402336"/>
+          </a:xfrm>
+          <a:prstGeom prst="ellipse">
+            <a:avLst/>
+          </a:prstGeom>
+          <a:solidFill>
+            <a:schemeClr val="accent6"/>
+          </a:solidFill>
+          <a:ln w="12700">
+            <a:solidFill>
+              <a:schemeClr val="accent6"/>
+            </a:solidFill>
+            <a:prstDash val="solid"/>
+          </a:ln>
+        </p:spPr>
+      </p:sp>
+      <p:pic>
+        <p:nvPicPr>
+          <p:cNvPr id="33" name="Image 5" descr="CircleCheck">    </p:cNvPr>
+          <p:cNvPicPr>
+            <a:picLocks noChangeAspect="1"/>
+          </p:cNvPicPr>
+          <p:nvPr/>
+        </p:nvPicPr>
+        <p:blipFill>
+          <a:blip r:embed="rId6"/>
+          <a:stretch>
+            <a:fillRect/>
+          </a:stretch>
+        </p:blipFill>
+        <p:spPr>
+          <a:xfrm>
+            <a:off x="7507224" y="3986784"/>
+            <a:ext cx="201168" cy="201168"/>
+          </a:xfrm>
+          <a:prstGeom prst="rect">
+            <a:avLst/>
+          </a:prstGeom>
+        </p:spPr>
+      </p:pic>
+      <p:sp>
+        <p:nvSpPr>
+          <p:cNvPr id="34" name="Text 26"/>
           <p:cNvSpPr txBox="1"/>
           <p:nvPr/>
         </p:nvSpPr>
         <p:spPr>
           <a:xfrm>
-            <a:off x="7223760" y="3712464"/>
-            <a:ext cx="4236415" cy="786384"/>
+            <a:off x="7927848" y="3758184"/>
+            <a:ext cx="3596335" cy="694944"/>
           </a:xfrm>
           <a:prstGeom prst="rect">
             <a:avLst/>
@@ -6264,18 +6682,18 @@
       </p:sp>
       <p:sp>
         <p:nvSpPr>
-          <p:cNvPr id="20" name="Shape 18"/>
+          <p:cNvPr id="35" name="Shape 27"/>
           <p:cNvSpPr/>
           <p:nvPr/>
         </p:nvSpPr>
         <p:spPr>
           <a:xfrm>
-            <a:off x="548640" y="4608576"/>
-            <a:ext cx="6035040" cy="786384"/>
+            <a:off x="548640" y="4562856"/>
+            <a:ext cx="6309360" cy="694944"/>
           </a:xfrm>
           <a:prstGeom prst="roundRect">
             <a:avLst>
-              <a:gd name="adj" fmla="val 13953"/>
+              <a:gd name="adj" fmla="val 15789"/>
             </a:avLst>
           </a:prstGeom>
           <a:solidFill>
@@ -6298,14 +6716,63 @@
       </p:sp>
       <p:sp>
         <p:nvSpPr>
-          <p:cNvPr id="21" name="Text 19"/>
+          <p:cNvPr id="36" name="Shape 28"/>
+          <p:cNvSpPr/>
+          <p:nvPr/>
+        </p:nvSpPr>
+        <p:spPr>
+          <a:xfrm>
+            <a:off x="685800" y="4663440"/>
+            <a:ext cx="457200" cy="457200"/>
+          </a:xfrm>
+          <a:prstGeom prst="ellipse">
+            <a:avLst/>
+          </a:prstGeom>
+          <a:solidFill>
+            <a:schemeClr val="accent5"/>
+          </a:solidFill>
+          <a:ln w="12700">
+            <a:solidFill>
+              <a:schemeClr val="accent5"/>
+            </a:solidFill>
+            <a:prstDash val="solid"/>
+          </a:ln>
+        </p:spPr>
+      </p:sp>
+      <p:pic>
+        <p:nvPicPr>
+          <p:cNvPr id="37" name="Image 6" descr="Plug">    </p:cNvPr>
+          <p:cNvPicPr>
+            <a:picLocks noChangeAspect="1"/>
+          </p:cNvPicPr>
+          <p:nvPr/>
+        </p:nvPicPr>
+        <p:blipFill>
+          <a:blip r:embed="rId7"/>
+          <a:stretch>
+            <a:fillRect/>
+          </a:stretch>
+        </p:blipFill>
+        <p:spPr>
+          <a:xfrm>
+            <a:off x="800100" y="4777740"/>
+            <a:ext cx="228600" cy="228600"/>
+          </a:xfrm>
+          <a:prstGeom prst="rect">
+            <a:avLst/>
+          </a:prstGeom>
+        </p:spPr>
+      </p:pic>
+      <p:sp>
+        <p:nvSpPr>
+          <p:cNvPr id="38" name="Text 29"/>
           <p:cNvSpPr txBox="1"/>
           <p:nvPr/>
         </p:nvSpPr>
         <p:spPr>
           <a:xfrm>
-            <a:off x="731520" y="4608576"/>
-            <a:ext cx="5669280" cy="786384"/>
+            <a:off x="1280160" y="4562856"/>
+            <a:ext cx="5440680" cy="694944"/>
           </a:xfrm>
           <a:prstGeom prst="rect">
             <a:avLst/>
@@ -6334,13 +6801,13 @@
       </p:sp>
       <p:sp>
         <p:nvSpPr>
-          <p:cNvPr id="22" name="Shape 20"/>
+          <p:cNvPr id="39" name="Shape 30"/>
           <p:cNvSpPr/>
           <p:nvPr/>
         </p:nvSpPr>
         <p:spPr>
           <a:xfrm>
-            <a:off x="6675120" y="4882896"/>
+            <a:off x="6922008" y="4791456"/>
             <a:ext cx="274320" cy="237744"/>
           </a:xfrm>
           <a:prstGeom prst="rightArrow">
@@ -6359,18 +6826,18 @@
       </p:sp>
       <p:sp>
         <p:nvSpPr>
-          <p:cNvPr id="23" name="Shape 21"/>
+          <p:cNvPr id="40" name="Shape 31"/>
           <p:cNvSpPr/>
           <p:nvPr/>
         </p:nvSpPr>
         <p:spPr>
           <a:xfrm>
-            <a:off x="7040880" y="4608576"/>
-            <a:ext cx="4602175" cy="786384"/>
+            <a:off x="7269480" y="4562856"/>
+            <a:ext cx="4373575" cy="694944"/>
           </a:xfrm>
           <a:prstGeom prst="roundRect">
             <a:avLst>
-              <a:gd name="adj" fmla="val 13953"/>
+              <a:gd name="adj" fmla="val 15789"/>
             </a:avLst>
           </a:prstGeom>
           <a:solidFill>
@@ -6386,14 +6853,63 @@
       </p:sp>
       <p:sp>
         <p:nvSpPr>
-          <p:cNvPr id="24" name="Text 22"/>
+          <p:cNvPr id="41" name="Shape 32"/>
+          <p:cNvSpPr/>
+          <p:nvPr/>
+        </p:nvSpPr>
+        <p:spPr>
+          <a:xfrm>
+            <a:off x="7406640" y="4690872"/>
+            <a:ext cx="402336" cy="402336"/>
+          </a:xfrm>
+          <a:prstGeom prst="ellipse">
+            <a:avLst/>
+          </a:prstGeom>
+          <a:solidFill>
+            <a:schemeClr val="accent6"/>
+          </a:solidFill>
+          <a:ln w="12700">
+            <a:solidFill>
+              <a:schemeClr val="accent6"/>
+            </a:solidFill>
+            <a:prstDash val="solid"/>
+          </a:ln>
+        </p:spPr>
+      </p:sp>
+      <p:pic>
+        <p:nvPicPr>
+          <p:cNvPr id="42" name="Image 7" descr="CircleCheck">    </p:cNvPr>
+          <p:cNvPicPr>
+            <a:picLocks noChangeAspect="1"/>
+          </p:cNvPicPr>
+          <p:nvPr/>
+        </p:nvPicPr>
+        <p:blipFill>
+          <a:blip r:embed="rId8"/>
+          <a:stretch>
+            <a:fillRect/>
+          </a:stretch>
+        </p:blipFill>
+        <p:spPr>
+          <a:xfrm>
+            <a:off x="7507224" y="4791456"/>
+            <a:ext cx="201168" cy="201168"/>
+          </a:xfrm>
+          <a:prstGeom prst="rect">
+            <a:avLst/>
+          </a:prstGeom>
+        </p:spPr>
+      </p:pic>
+      <p:sp>
+        <p:nvSpPr>
+          <p:cNvPr id="43" name="Text 33"/>
           <p:cNvSpPr txBox="1"/>
           <p:nvPr/>
         </p:nvSpPr>
         <p:spPr>
           <a:xfrm>
-            <a:off x="7223760" y="4608576"/>
-            <a:ext cx="4236415" cy="786384"/>
+            <a:off x="7927848" y="4562856"/>
+            <a:ext cx="3596335" cy="694944"/>
           </a:xfrm>
           <a:prstGeom prst="rect">
             <a:avLst/>
@@ -6422,18 +6938,18 @@
       </p:sp>
       <p:sp>
         <p:nvSpPr>
-          <p:cNvPr id="25" name="Shape 23"/>
+          <p:cNvPr id="44" name="Shape 34"/>
           <p:cNvSpPr/>
           <p:nvPr/>
         </p:nvSpPr>
         <p:spPr>
           <a:xfrm>
-            <a:off x="548640" y="5504688"/>
-            <a:ext cx="6035040" cy="786384"/>
+            <a:off x="548640" y="5367528"/>
+            <a:ext cx="6309360" cy="694944"/>
           </a:xfrm>
           <a:prstGeom prst="roundRect">
             <a:avLst>
-              <a:gd name="adj" fmla="val 13953"/>
+              <a:gd name="adj" fmla="val 15789"/>
             </a:avLst>
           </a:prstGeom>
           <a:solidFill>
@@ -6456,14 +6972,63 @@
       </p:sp>
       <p:sp>
         <p:nvSpPr>
-          <p:cNvPr id="26" name="Text 24"/>
+          <p:cNvPr id="45" name="Shape 35"/>
+          <p:cNvSpPr/>
+          <p:nvPr/>
+        </p:nvSpPr>
+        <p:spPr>
+          <a:xfrm>
+            <a:off x="685800" y="5468112"/>
+            <a:ext cx="457200" cy="457200"/>
+          </a:xfrm>
+          <a:prstGeom prst="ellipse">
+            <a:avLst/>
+          </a:prstGeom>
+          <a:solidFill>
+            <a:schemeClr val="accent1"/>
+          </a:solidFill>
+          <a:ln w="12700">
+            <a:solidFill>
+              <a:schemeClr val="accent1"/>
+            </a:solidFill>
+            <a:prstDash val="solid"/>
+          </a:ln>
+        </p:spPr>
+      </p:sp>
+      <p:pic>
+        <p:nvPicPr>
+          <p:cNvPr id="46" name="Image 8" descr="Coins">    </p:cNvPr>
+          <p:cNvPicPr>
+            <a:picLocks noChangeAspect="1"/>
+          </p:cNvPicPr>
+          <p:nvPr/>
+        </p:nvPicPr>
+        <p:blipFill>
+          <a:blip r:embed="rId9"/>
+          <a:stretch>
+            <a:fillRect/>
+          </a:stretch>
+        </p:blipFill>
+        <p:spPr>
+          <a:xfrm>
+            <a:off x="800100" y="5582412"/>
+            <a:ext cx="228600" cy="228600"/>
+          </a:xfrm>
+          <a:prstGeom prst="rect">
+            <a:avLst/>
+          </a:prstGeom>
+        </p:spPr>
+      </p:pic>
+      <p:sp>
+        <p:nvSpPr>
+          <p:cNvPr id="47" name="Text 36"/>
           <p:cNvSpPr txBox="1"/>
           <p:nvPr/>
         </p:nvSpPr>
         <p:spPr>
           <a:xfrm>
-            <a:off x="731520" y="5504688"/>
-            <a:ext cx="5669280" cy="786384"/>
+            <a:off x="1280160" y="5367528"/>
+            <a:ext cx="5440680" cy="694944"/>
           </a:xfrm>
           <a:prstGeom prst="rect">
             <a:avLst/>
@@ -6492,13 +7057,13 @@
       </p:sp>
       <p:sp>
         <p:nvSpPr>
-          <p:cNvPr id="27" name="Shape 25"/>
+          <p:cNvPr id="48" name="Shape 37"/>
           <p:cNvSpPr/>
           <p:nvPr/>
         </p:nvSpPr>
         <p:spPr>
           <a:xfrm>
-            <a:off x="6675120" y="5779008"/>
+            <a:off x="6922008" y="5596128"/>
             <a:ext cx="274320" cy="237744"/>
           </a:xfrm>
           <a:prstGeom prst="rightArrow">
@@ -6517,18 +7082,18 @@
       </p:sp>
       <p:sp>
         <p:nvSpPr>
-          <p:cNvPr id="28" name="Shape 26"/>
+          <p:cNvPr id="49" name="Shape 38"/>
           <p:cNvSpPr/>
           <p:nvPr/>
         </p:nvSpPr>
         <p:spPr>
           <a:xfrm>
-            <a:off x="7040880" y="5504688"/>
-            <a:ext cx="4602175" cy="786384"/>
+            <a:off x="7269480" y="5367528"/>
+            <a:ext cx="4373575" cy="694944"/>
           </a:xfrm>
           <a:prstGeom prst="roundRect">
             <a:avLst>
-              <a:gd name="adj" fmla="val 13953"/>
+              <a:gd name="adj" fmla="val 15789"/>
             </a:avLst>
           </a:prstGeom>
           <a:solidFill>
@@ -6544,14 +7109,63 @@
       </p:sp>
       <p:sp>
         <p:nvSpPr>
-          <p:cNvPr id="29" name="Text 27"/>
+          <p:cNvPr id="50" name="Shape 39"/>
+          <p:cNvSpPr/>
+          <p:nvPr/>
+        </p:nvSpPr>
+        <p:spPr>
+          <a:xfrm>
+            <a:off x="7406640" y="5495544"/>
+            <a:ext cx="402336" cy="402336"/>
+          </a:xfrm>
+          <a:prstGeom prst="ellipse">
+            <a:avLst/>
+          </a:prstGeom>
+          <a:solidFill>
+            <a:schemeClr val="accent6"/>
+          </a:solidFill>
+          <a:ln w="12700">
+            <a:solidFill>
+              <a:schemeClr val="accent6"/>
+            </a:solidFill>
+            <a:prstDash val="solid"/>
+          </a:ln>
+        </p:spPr>
+      </p:sp>
+      <p:pic>
+        <p:nvPicPr>
+          <p:cNvPr id="51" name="Image 9" descr="CircleCheck">    </p:cNvPr>
+          <p:cNvPicPr>
+            <a:picLocks noChangeAspect="1"/>
+          </p:cNvPicPr>
+          <p:nvPr/>
+        </p:nvPicPr>
+        <p:blipFill>
+          <a:blip r:embed="rId10"/>
+          <a:stretch>
+            <a:fillRect/>
+          </a:stretch>
+        </p:blipFill>
+        <p:spPr>
+          <a:xfrm>
+            <a:off x="7507224" y="5596128"/>
+            <a:ext cx="201168" cy="201168"/>
+          </a:xfrm>
+          <a:prstGeom prst="rect">
+            <a:avLst/>
+          </a:prstGeom>
+        </p:spPr>
+      </p:pic>
+      <p:sp>
+        <p:nvSpPr>
+          <p:cNvPr id="52" name="Text 40"/>
           <p:cNvSpPr txBox="1"/>
           <p:nvPr/>
         </p:nvSpPr>
         <p:spPr>
           <a:xfrm>
-            <a:off x="7223760" y="5504688"/>
-            <a:ext cx="4236415" cy="786384"/>
+            <a:off x="7927848" y="5367528"/>
+            <a:ext cx="3596335" cy="694944"/>
           </a:xfrm>
           <a:prstGeom prst="rect">
             <a:avLst/>
@@ -8052,7 +8666,7 @@
         <p:spPr>
           <a:xfrm>
             <a:off x="548640" y="1508760"/>
-            <a:ext cx="5364328" cy="4526280"/>
+            <a:ext cx="5486400" cy="4526280"/>
           </a:xfrm>
           <a:prstGeom prst="roundRect">
             <a:avLst>
@@ -8085,8 +8699,8 @@
         </p:nvSpPr>
         <p:spPr>
           <a:xfrm>
-            <a:off x="822960" y="1645920"/>
-            <a:ext cx="4815688" cy="457200"/>
+            <a:off x="822960" y="1627632"/>
+            <a:ext cx="4937760" cy="457200"/>
           </a:xfrm>
           <a:prstGeom prst="rect">
             <a:avLst/>
@@ -8102,27 +8716,54 @@
               <a:buNone/>
             </a:pPr>
             <a:r>
-              <a:rPr lang="en-US" sz="2200" b="1" dirty="0">
+              <a:rPr lang="en-US" sz="2000" b="1" dirty="0">
                 <a:solidFill>
                   <a:schemeClr val="accent4"/>
                 </a:solidFill>
               </a:rPr>
-              <a:t>Honest limits</a:t>
-            </a:r>
-            <a:endParaRPr lang="en-US" sz="2200" dirty="0"/>
-          </a:p>
-        </p:txBody>
-      </p:sp>
-      <p:sp>
-        <p:nvSpPr>
-          <p:cNvPr id="5" name="Text 3"/>
+              <a:t>What we have and have not tested</a:t>
+            </a:r>
+            <a:endParaRPr lang="en-US" sz="2000" dirty="0"/>
+          </a:p>
+        </p:txBody>
+      </p:sp>
+      <p:sp>
+        <p:nvSpPr>
+          <p:cNvPr id="5" name="Shape 3"/>
+          <p:cNvSpPr/>
+          <p:nvPr/>
+        </p:nvSpPr>
+        <p:spPr>
+          <a:xfrm>
+            <a:off x="777240" y="2194560"/>
+            <a:ext cx="5029200" cy="457200"/>
+          </a:xfrm>
+          <a:prstGeom prst="roundRect">
+            <a:avLst>
+              <a:gd name="adj" fmla="val 16000"/>
+            </a:avLst>
+          </a:prstGeom>
+          <a:solidFill>
+            <a:srgbClr val="F0FDFA"/>
+          </a:solidFill>
+          <a:ln w="9525">
+            <a:solidFill>
+              <a:srgbClr val="E4ECE8"/>
+            </a:solidFill>
+            <a:prstDash val="solid"/>
+          </a:ln>
+        </p:spPr>
+      </p:sp>
+      <p:sp>
+        <p:nvSpPr>
+          <p:cNvPr id="6" name="Text 4"/>
           <p:cNvSpPr txBox="1"/>
           <p:nvPr/>
         </p:nvSpPr>
         <p:spPr>
           <a:xfrm>
-            <a:off x="822960" y="2194560"/>
-            <a:ext cx="4815688" cy="3749040"/>
+            <a:off x="914400" y="2194560"/>
+            <a:ext cx="3429000" cy="457200"/>
           </a:xfrm>
           <a:prstGeom prst="rect">
             <a:avLst/>
@@ -8131,110 +8772,625 @@
           <a:ln/>
         </p:spPr>
         <p:txBody>
-          <a:bodyPr wrap="square" lIns="635" tIns="635" rIns="635" bIns="635" rtlCol="0" anchor="t"/>
-          <a:lstStyle/>
-          <a:p>
-            <a:pPr marL="177800" indent="-177800">
-              <a:spcAft>
-                <a:spcPts val="1200"/>
-              </a:spcAft>
-              <a:buSzPct val="100000"/>
-              <a:buChar char="•"/>
-            </a:pPr>
-            <a:r>
-              <a:rPr lang="en-US" sz="1700" dirty="0">
+          <a:bodyPr wrap="square" lIns="0" tIns="0" rIns="0" bIns="0" rtlCol="0" anchor="ctr"/>
+          <a:lstStyle/>
+          <a:p>
+            <a:pPr indent="0" marL="0">
+              <a:buNone/>
+            </a:pPr>
+            <a:r>
+              <a:rPr lang="en-US" sz="1300" dirty="0">
                 <a:solidFill>
                   <a:schemeClr val="tx1"/>
                 </a:solidFill>
               </a:rPr>
-              <a:t>Synthetic documents, one model: this shows the logic, not real-world accuracy</a:t>
-            </a:r>
-            <a:endParaRPr lang="en-US" sz="1700" dirty="0"/>
-          </a:p>
-          <a:p>
-            <a:pPr marL="177800" indent="-177800">
-              <a:spcAft>
-                <a:spcPts val="1200"/>
-              </a:spcAft>
-              <a:buSzPct val="100000"/>
-              <a:buChar char="•"/>
-            </a:pPr>
-            <a:r>
-              <a:rPr lang="en-US" sz="1700" dirty="0">
+              <a:t>English, typed deeds (digital and scanned)</a:t>
+            </a:r>
+            <a:endParaRPr lang="en-US" sz="1300" dirty="0"/>
+          </a:p>
+        </p:txBody>
+      </p:sp>
+      <p:sp>
+        <p:nvSpPr>
+          <p:cNvPr id="7" name="Text 5"/>
+          <p:cNvSpPr txBox="1"/>
+          <p:nvPr/>
+        </p:nvSpPr>
+        <p:spPr>
+          <a:xfrm>
+            <a:off x="4480560" y="2249424"/>
+            <a:ext cx="1234440" cy="347472"/>
+          </a:xfrm>
+          <a:prstGeom prst="roundRect">
+            <a:avLst>
+              <a:gd name="adj" fmla="val 26316"/>
+            </a:avLst>
+          </a:prstGeom>
+          <a:solidFill>
+            <a:schemeClr val="accent6"/>
+          </a:solidFill>
+          <a:ln/>
+        </p:spPr>
+        <p:txBody>
+          <a:bodyPr wrap="square" lIns="0" tIns="0" rIns="0" bIns="0" rtlCol="0" anchor="ctr"/>
+          <a:lstStyle/>
+          <a:p>
+            <a:pPr algn="ctr" indent="0" marL="0">
+              <a:buNone/>
+            </a:pPr>
+            <a:r>
+              <a:rPr lang="en-US" sz="1300" b="1" dirty="0">
+                <a:solidFill>
+                  <a:schemeClr val="bg1"/>
+                </a:solidFill>
+              </a:rPr>
+              <a:t>Tested</a:t>
+            </a:r>
+            <a:endParaRPr lang="en-US" sz="1300" dirty="0"/>
+          </a:p>
+        </p:txBody>
+      </p:sp>
+      <p:sp>
+        <p:nvSpPr>
+          <p:cNvPr id="8" name="Shape 6"/>
+          <p:cNvSpPr/>
+          <p:nvPr/>
+        </p:nvSpPr>
+        <p:spPr>
+          <a:xfrm>
+            <a:off x="777240" y="2724912"/>
+            <a:ext cx="5029200" cy="457200"/>
+          </a:xfrm>
+          <a:prstGeom prst="roundRect">
+            <a:avLst>
+              <a:gd name="adj" fmla="val 16000"/>
+            </a:avLst>
+          </a:prstGeom>
+          <a:solidFill>
+            <a:schemeClr val="bg1"/>
+          </a:solidFill>
+          <a:ln w="9525">
+            <a:solidFill>
+              <a:srgbClr val="E4ECE8"/>
+            </a:solidFill>
+            <a:prstDash val="solid"/>
+          </a:ln>
+        </p:spPr>
+      </p:sp>
+      <p:sp>
+        <p:nvSpPr>
+          <p:cNvPr id="9" name="Text 7"/>
+          <p:cNvSpPr txBox="1"/>
+          <p:nvPr/>
+        </p:nvSpPr>
+        <p:spPr>
+          <a:xfrm>
+            <a:off x="914400" y="2724912"/>
+            <a:ext cx="3429000" cy="457200"/>
+          </a:xfrm>
+          <a:prstGeom prst="rect">
+            <a:avLst/>
+          </a:prstGeom>
+          <a:noFill/>
+          <a:ln/>
+        </p:spPr>
+        <p:txBody>
+          <a:bodyPr wrap="square" lIns="0" tIns="0" rIns="0" bIns="0" rtlCol="0" anchor="ctr"/>
+          <a:lstStyle/>
+          <a:p>
+            <a:pPr indent="0" marL="0">
+              <a:buNone/>
+            </a:pPr>
+            <a:r>
+              <a:rPr lang="en-US" sz="1300" dirty="0">
                 <a:solidFill>
                   <a:schemeClr val="tx1"/>
                 </a:solidFill>
               </a:rPr>
-              <a:t>English and Hindi tested; Assamese not tested</a:t>
-            </a:r>
-            <a:endParaRPr lang="en-US" sz="1700" dirty="0"/>
-          </a:p>
-          <a:p>
-            <a:pPr marL="177800" indent="-177800">
-              <a:spcAft>
-                <a:spcPts val="1200"/>
-              </a:spcAft>
-              <a:buSzPct val="100000"/>
-              <a:buChar char="•"/>
-            </a:pPr>
-            <a:r>
-              <a:rPr lang="en-US" sz="1700" dirty="0">
+              <a:t>Hindi, typed deeds (digital and scanned)</a:t>
+            </a:r>
+            <a:endParaRPr lang="en-US" sz="1300" dirty="0"/>
+          </a:p>
+        </p:txBody>
+      </p:sp>
+      <p:sp>
+        <p:nvSpPr>
+          <p:cNvPr id="10" name="Text 8"/>
+          <p:cNvSpPr txBox="1"/>
+          <p:nvPr/>
+        </p:nvSpPr>
+        <p:spPr>
+          <a:xfrm>
+            <a:off x="4480560" y="2779776"/>
+            <a:ext cx="1234440" cy="347472"/>
+          </a:xfrm>
+          <a:prstGeom prst="roundRect">
+            <a:avLst>
+              <a:gd name="adj" fmla="val 26316"/>
+            </a:avLst>
+          </a:prstGeom>
+          <a:solidFill>
+            <a:schemeClr val="accent6"/>
+          </a:solidFill>
+          <a:ln/>
+        </p:spPr>
+        <p:txBody>
+          <a:bodyPr wrap="square" lIns="0" tIns="0" rIns="0" bIns="0" rtlCol="0" anchor="ctr"/>
+          <a:lstStyle/>
+          <a:p>
+            <a:pPr algn="ctr" indent="0" marL="0">
+              <a:buNone/>
+            </a:pPr>
+            <a:r>
+              <a:rPr lang="en-US" sz="1300" b="1" dirty="0">
+                <a:solidFill>
+                  <a:schemeClr val="bg1"/>
+                </a:solidFill>
+              </a:rPr>
+              <a:t>Tested</a:t>
+            </a:r>
+            <a:endParaRPr lang="en-US" sz="1300" dirty="0"/>
+          </a:p>
+        </p:txBody>
+      </p:sp>
+      <p:sp>
+        <p:nvSpPr>
+          <p:cNvPr id="11" name="Shape 9"/>
+          <p:cNvSpPr/>
+          <p:nvPr/>
+        </p:nvSpPr>
+        <p:spPr>
+          <a:xfrm>
+            <a:off x="777240" y="3255264"/>
+            <a:ext cx="5029200" cy="457200"/>
+          </a:xfrm>
+          <a:prstGeom prst="roundRect">
+            <a:avLst>
+              <a:gd name="adj" fmla="val 16000"/>
+            </a:avLst>
+          </a:prstGeom>
+          <a:solidFill>
+            <a:srgbClr val="F0FDFA"/>
+          </a:solidFill>
+          <a:ln w="9525">
+            <a:solidFill>
+              <a:srgbClr val="E4ECE8"/>
+            </a:solidFill>
+            <a:prstDash val="solid"/>
+          </a:ln>
+        </p:spPr>
+      </p:sp>
+      <p:sp>
+        <p:nvSpPr>
+          <p:cNvPr id="12" name="Text 10"/>
+          <p:cNvSpPr txBox="1"/>
+          <p:nvPr/>
+        </p:nvSpPr>
+        <p:spPr>
+          <a:xfrm>
+            <a:off x="914400" y="3255264"/>
+            <a:ext cx="3429000" cy="457200"/>
+          </a:xfrm>
+          <a:prstGeom prst="rect">
+            <a:avLst/>
+          </a:prstGeom>
+          <a:noFill/>
+          <a:ln/>
+        </p:spPr>
+        <p:txBody>
+          <a:bodyPr wrap="square" lIns="0" tIns="0" rIns="0" bIns="0" rtlCol="0" anchor="ctr"/>
+          <a:lstStyle/>
+          <a:p>
+            <a:pPr indent="0" marL="0">
+              <a:buNone/>
+            </a:pPr>
+            <a:r>
+              <a:rPr lang="en-US" sz="1300" dirty="0">
                 <a:solidFill>
                   <a:schemeClr val="tx1"/>
                 </a:solidFill>
               </a:rPr>
-              <a:t>Handwriting tested with a handwriting font, which is tidier than real writing</a:t>
-            </a:r>
-            <a:endParaRPr lang="en-US" sz="1700" dirty="0"/>
-          </a:p>
-          <a:p>
-            <a:pPr marL="177800" indent="-177800">
-              <a:spcAft>
-                <a:spcPts val="1200"/>
-              </a:spcAft>
-              <a:buSzPct val="100000"/>
-              <a:buChar char="•"/>
-            </a:pPr>
-            <a:r>
-              <a:rPr lang="en-US" sz="1700" dirty="0">
+              <a:t>Handwriting, using a handwriting font</a:t>
+            </a:r>
+            <a:endParaRPr lang="en-US" sz="1300" dirty="0"/>
+          </a:p>
+        </p:txBody>
+      </p:sp>
+      <p:sp>
+        <p:nvSpPr>
+          <p:cNvPr id="13" name="Text 11"/>
+          <p:cNvSpPr txBox="1"/>
+          <p:nvPr/>
+        </p:nvSpPr>
+        <p:spPr>
+          <a:xfrm>
+            <a:off x="4480560" y="3310128"/>
+            <a:ext cx="1234440" cy="347472"/>
+          </a:xfrm>
+          <a:prstGeom prst="roundRect">
+            <a:avLst>
+              <a:gd name="adj" fmla="val 26316"/>
+            </a:avLst>
+          </a:prstGeom>
+          <a:solidFill>
+            <a:schemeClr val="accent4"/>
+          </a:solidFill>
+          <a:ln/>
+        </p:spPr>
+        <p:txBody>
+          <a:bodyPr wrap="square" lIns="0" tIns="0" rIns="0" bIns="0" rtlCol="0" anchor="ctr"/>
+          <a:lstStyle/>
+          <a:p>
+            <a:pPr algn="ctr" indent="0" marL="0">
+              <a:buNone/>
+            </a:pPr>
+            <a:r>
+              <a:rPr lang="en-US" sz="1300" b="1" dirty="0">
+                <a:solidFill>
+                  <a:schemeClr val="bg1"/>
+                </a:solidFill>
+              </a:rPr>
+              <a:t>Partly</a:t>
+            </a:r>
+            <a:endParaRPr lang="en-US" sz="1300" dirty="0"/>
+          </a:p>
+        </p:txBody>
+      </p:sp>
+      <p:sp>
+        <p:nvSpPr>
+          <p:cNvPr id="14" name="Shape 12"/>
+          <p:cNvSpPr/>
+          <p:nvPr/>
+        </p:nvSpPr>
+        <p:spPr>
+          <a:xfrm>
+            <a:off x="777240" y="3785616"/>
+            <a:ext cx="5029200" cy="457200"/>
+          </a:xfrm>
+          <a:prstGeom prst="roundRect">
+            <a:avLst>
+              <a:gd name="adj" fmla="val 16000"/>
+            </a:avLst>
+          </a:prstGeom>
+          <a:solidFill>
+            <a:schemeClr val="bg1"/>
+          </a:solidFill>
+          <a:ln w="9525">
+            <a:solidFill>
+              <a:srgbClr val="E4ECE8"/>
+            </a:solidFill>
+            <a:prstDash val="solid"/>
+          </a:ln>
+        </p:spPr>
+      </p:sp>
+      <p:sp>
+        <p:nvSpPr>
+          <p:cNvPr id="15" name="Text 13"/>
+          <p:cNvSpPr txBox="1"/>
+          <p:nvPr/>
+        </p:nvSpPr>
+        <p:spPr>
+          <a:xfrm>
+            <a:off x="914400" y="3785616"/>
+            <a:ext cx="3429000" cy="457200"/>
+          </a:xfrm>
+          <a:prstGeom prst="rect">
+            <a:avLst/>
+          </a:prstGeom>
+          <a:noFill/>
+          <a:ln/>
+        </p:spPr>
+        <p:txBody>
+          <a:bodyPr wrap="square" lIns="0" tIns="0" rIns="0" bIns="0" rtlCol="0" anchor="ctr"/>
+          <a:lstStyle/>
+          <a:p>
+            <a:pPr indent="0" marL="0">
+              <a:buNone/>
+            </a:pPr>
+            <a:r>
+              <a:rPr lang="en-US" sz="1300" dirty="0">
                 <a:solidFill>
                   <a:schemeClr val="tx1"/>
                 </a:solidFill>
               </a:rPr>
-              <a:t>Handwritten ID numbers cannot be masked automatically</a:t>
-            </a:r>
-            <a:endParaRPr lang="en-US" sz="1700" dirty="0"/>
-          </a:p>
-          <a:p>
-            <a:pPr marL="177800" indent="-177800">
-              <a:spcAft>
-                <a:spcPts val="1200"/>
-              </a:spcAft>
-              <a:buSzPct val="100000"/>
-              <a:buChar char="•"/>
-            </a:pPr>
-            <a:r>
-              <a:rPr lang="en-US" sz="1700" dirty="0">
+              <a:t>Real handwritten deeds</a:t>
+            </a:r>
+            <a:endParaRPr lang="en-US" sz="1300" dirty="0"/>
+          </a:p>
+        </p:txBody>
+      </p:sp>
+      <p:sp>
+        <p:nvSpPr>
+          <p:cNvPr id="16" name="Text 14"/>
+          <p:cNvSpPr txBox="1"/>
+          <p:nvPr/>
+        </p:nvSpPr>
+        <p:spPr>
+          <a:xfrm>
+            <a:off x="4480560" y="3840480"/>
+            <a:ext cx="1234440" cy="347472"/>
+          </a:xfrm>
+          <a:prstGeom prst="roundRect">
+            <a:avLst>
+              <a:gd name="adj" fmla="val 26316"/>
+            </a:avLst>
+          </a:prstGeom>
+          <a:solidFill>
+            <a:schemeClr val="accent3"/>
+          </a:solidFill>
+          <a:ln/>
+        </p:spPr>
+        <p:txBody>
+          <a:bodyPr wrap="square" lIns="0" tIns="0" rIns="0" bIns="0" rtlCol="0" anchor="ctr"/>
+          <a:lstStyle/>
+          <a:p>
+            <a:pPr algn="ctr" indent="0" marL="0">
+              <a:buNone/>
+            </a:pPr>
+            <a:r>
+              <a:rPr lang="en-US" sz="1300" b="1" dirty="0">
+                <a:solidFill>
+                  <a:schemeClr val="bg1"/>
+                </a:solidFill>
+              </a:rPr>
+              <a:t>Not tested</a:t>
+            </a:r>
+            <a:endParaRPr lang="en-US" sz="1300" dirty="0"/>
+          </a:p>
+        </p:txBody>
+      </p:sp>
+      <p:sp>
+        <p:nvSpPr>
+          <p:cNvPr id="17" name="Shape 15"/>
+          <p:cNvSpPr/>
+          <p:nvPr/>
+        </p:nvSpPr>
+        <p:spPr>
+          <a:xfrm>
+            <a:off x="777240" y="4315968"/>
+            <a:ext cx="5029200" cy="457200"/>
+          </a:xfrm>
+          <a:prstGeom prst="roundRect">
+            <a:avLst>
+              <a:gd name="adj" fmla="val 16000"/>
+            </a:avLst>
+          </a:prstGeom>
+          <a:solidFill>
+            <a:srgbClr val="F0FDFA"/>
+          </a:solidFill>
+          <a:ln w="9525">
+            <a:solidFill>
+              <a:srgbClr val="E4ECE8"/>
+            </a:solidFill>
+            <a:prstDash val="solid"/>
+          </a:ln>
+        </p:spPr>
+      </p:sp>
+      <p:sp>
+        <p:nvSpPr>
+          <p:cNvPr id="18" name="Text 16"/>
+          <p:cNvSpPr txBox="1"/>
+          <p:nvPr/>
+        </p:nvSpPr>
+        <p:spPr>
+          <a:xfrm>
+            <a:off x="914400" y="4315968"/>
+            <a:ext cx="3429000" cy="457200"/>
+          </a:xfrm>
+          <a:prstGeom prst="rect">
+            <a:avLst/>
+          </a:prstGeom>
+          <a:noFill/>
+          <a:ln/>
+        </p:spPr>
+        <p:txBody>
+          <a:bodyPr wrap="square" lIns="0" tIns="0" rIns="0" bIns="0" rtlCol="0" anchor="ctr"/>
+          <a:lstStyle/>
+          <a:p>
+            <a:pPr indent="0" marL="0">
+              <a:buNone/>
+            </a:pPr>
+            <a:r>
+              <a:rPr lang="en-US" sz="1300" dirty="0">
                 <a:solidFill>
                   <a:schemeClr val="tx1"/>
                 </a:solidFill>
               </a:rPr>
-              <a:t>A deed-only view cannot see inheritance, mutations or litigation</a:t>
-            </a:r>
-            <a:endParaRPr lang="en-US" sz="1700" dirty="0"/>
-          </a:p>
-        </p:txBody>
-      </p:sp>
-      <p:sp>
-        <p:nvSpPr>
-          <p:cNvPr id="6" name="Shape 4"/>
+              <a:t>Assamese deeds</a:t>
+            </a:r>
+            <a:endParaRPr lang="en-US" sz="1300" dirty="0"/>
+          </a:p>
+        </p:txBody>
+      </p:sp>
+      <p:sp>
+        <p:nvSpPr>
+          <p:cNvPr id="19" name="Text 17"/>
+          <p:cNvSpPr txBox="1"/>
+          <p:nvPr/>
+        </p:nvSpPr>
+        <p:spPr>
+          <a:xfrm>
+            <a:off x="4480560" y="4370832"/>
+            <a:ext cx="1234440" cy="347472"/>
+          </a:xfrm>
+          <a:prstGeom prst="roundRect">
+            <a:avLst>
+              <a:gd name="adj" fmla="val 26316"/>
+            </a:avLst>
+          </a:prstGeom>
+          <a:solidFill>
+            <a:schemeClr val="accent3"/>
+          </a:solidFill>
+          <a:ln/>
+        </p:spPr>
+        <p:txBody>
+          <a:bodyPr wrap="square" lIns="0" tIns="0" rIns="0" bIns="0" rtlCol="0" anchor="ctr"/>
+          <a:lstStyle/>
+          <a:p>
+            <a:pPr algn="ctr" indent="0" marL="0">
+              <a:buNone/>
+            </a:pPr>
+            <a:r>
+              <a:rPr lang="en-US" sz="1300" b="1" dirty="0">
+                <a:solidFill>
+                  <a:schemeClr val="bg1"/>
+                </a:solidFill>
+              </a:rPr>
+              <a:t>Not tested</a:t>
+            </a:r>
+            <a:endParaRPr lang="en-US" sz="1300" dirty="0"/>
+          </a:p>
+        </p:txBody>
+      </p:sp>
+      <p:sp>
+        <p:nvSpPr>
+          <p:cNvPr id="20" name="Shape 18"/>
           <p:cNvSpPr/>
           <p:nvPr/>
         </p:nvSpPr>
         <p:spPr>
           <a:xfrm>
-            <a:off x="6278728" y="1508760"/>
-            <a:ext cx="5364328" cy="4526280"/>
+            <a:off x="777240" y="4846320"/>
+            <a:ext cx="5029200" cy="457200"/>
+          </a:xfrm>
+          <a:prstGeom prst="roundRect">
+            <a:avLst>
+              <a:gd name="adj" fmla="val 16000"/>
+            </a:avLst>
+          </a:prstGeom>
+          <a:solidFill>
+            <a:schemeClr val="bg1"/>
+          </a:solidFill>
+          <a:ln w="9525">
+            <a:solidFill>
+              <a:srgbClr val="E4ECE8"/>
+            </a:solidFill>
+            <a:prstDash val="solid"/>
+          </a:ln>
+        </p:spPr>
+      </p:sp>
+      <p:sp>
+        <p:nvSpPr>
+          <p:cNvPr id="21" name="Text 19"/>
+          <p:cNvSpPr txBox="1"/>
+          <p:nvPr/>
+        </p:nvSpPr>
+        <p:spPr>
+          <a:xfrm>
+            <a:off x="914400" y="4846320"/>
+            <a:ext cx="3429000" cy="457200"/>
+          </a:xfrm>
+          <a:prstGeom prst="rect">
+            <a:avLst/>
+          </a:prstGeom>
+          <a:noFill/>
+          <a:ln/>
+        </p:spPr>
+        <p:txBody>
+          <a:bodyPr wrap="square" lIns="0" tIns="0" rIns="0" bIns="0" rtlCol="0" anchor="ctr"/>
+          <a:lstStyle/>
+          <a:p>
+            <a:pPr indent="0" marL="0">
+              <a:buNone/>
+            </a:pPr>
+            <a:r>
+              <a:rPr lang="en-US" sz="1300" dirty="0">
+                <a:solidFill>
+                  <a:schemeClr val="tx1"/>
+                </a:solidFill>
+              </a:rPr>
+              <a:t>Real deeds and a real registry feed</a:t>
+            </a:r>
+            <a:endParaRPr lang="en-US" sz="1300" dirty="0"/>
+          </a:p>
+        </p:txBody>
+      </p:sp>
+      <p:sp>
+        <p:nvSpPr>
+          <p:cNvPr id="22" name="Text 20"/>
+          <p:cNvSpPr txBox="1"/>
+          <p:nvPr/>
+        </p:nvSpPr>
+        <p:spPr>
+          <a:xfrm>
+            <a:off x="4480560" y="4901184"/>
+            <a:ext cx="1234440" cy="347472"/>
+          </a:xfrm>
+          <a:prstGeom prst="roundRect">
+            <a:avLst>
+              <a:gd name="adj" fmla="val 26316"/>
+            </a:avLst>
+          </a:prstGeom>
+          <a:solidFill>
+            <a:schemeClr val="accent3"/>
+          </a:solidFill>
+          <a:ln/>
+        </p:spPr>
+        <p:txBody>
+          <a:bodyPr wrap="square" lIns="0" tIns="0" rIns="0" bIns="0" rtlCol="0" anchor="ctr"/>
+          <a:lstStyle/>
+          <a:p>
+            <a:pPr algn="ctr" indent="0" marL="0">
+              <a:buNone/>
+            </a:pPr>
+            <a:r>
+              <a:rPr lang="en-US" sz="1300" b="1" dirty="0">
+                <a:solidFill>
+                  <a:schemeClr val="bg1"/>
+                </a:solidFill>
+              </a:rPr>
+              <a:t>Not tested</a:t>
+            </a:r>
+            <a:endParaRPr lang="en-US" sz="1300" dirty="0"/>
+          </a:p>
+        </p:txBody>
+      </p:sp>
+      <p:sp>
+        <p:nvSpPr>
+          <p:cNvPr id="23" name="Text 21"/>
+          <p:cNvSpPr txBox="1"/>
+          <p:nvPr/>
+        </p:nvSpPr>
+        <p:spPr>
+          <a:xfrm>
+            <a:off x="822960" y="5440680"/>
+            <a:ext cx="4937760" cy="548640"/>
+          </a:xfrm>
+          <a:prstGeom prst="rect">
+            <a:avLst/>
+          </a:prstGeom>
+          <a:noFill/>
+          <a:ln/>
+        </p:spPr>
+        <p:txBody>
+          <a:bodyPr wrap="square" lIns="0" tIns="0" rIns="0" bIns="0" rtlCol="0" anchor="t"/>
+          <a:lstStyle/>
+          <a:p>
+            <a:pPr indent="0" marL="0">
+              <a:buNone/>
+            </a:pPr>
+            <a:r>
+              <a:rPr lang="en-US" sz="1200" dirty="0">
+                <a:solidFill>
+                  <a:srgbClr val="5B7276"/>
+                </a:solidFill>
+              </a:rPr>
+              <a:t>Also: handwritten ID numbers cannot be masked automatically, and a deed-only view cannot see inheritance, mutations or litigation.</a:t>
+            </a:r>
+            <a:endParaRPr lang="en-US" sz="1200" dirty="0"/>
+          </a:p>
+        </p:txBody>
+      </p:sp>
+      <p:sp>
+        <p:nvSpPr>
+          <p:cNvPr id="24" name="Shape 22"/>
+          <p:cNvSpPr/>
+          <p:nvPr/>
+        </p:nvSpPr>
+        <p:spPr>
+          <a:xfrm>
+            <a:off x="6309360" y="1508760"/>
+            <a:ext cx="5333695" cy="4526280"/>
           </a:xfrm>
           <a:prstGeom prst="roundRect">
             <a:avLst>
@@ -8261,14 +9417,14 @@
       </p:sp>
       <p:sp>
         <p:nvSpPr>
-          <p:cNvPr id="7" name="Text 5"/>
+          <p:cNvPr id="25" name="Text 23"/>
           <p:cNvSpPr txBox="1"/>
           <p:nvPr/>
         </p:nvSpPr>
         <p:spPr>
           <a:xfrm>
-            <a:off x="6553048" y="1645920"/>
-            <a:ext cx="4815688" cy="457200"/>
+            <a:off x="6583680" y="1627632"/>
+            <a:ext cx="4785055" cy="457200"/>
           </a:xfrm>
           <a:prstGeom prst="rect">
             <a:avLst/>
@@ -8284,27 +9440,101 @@
               <a:buNone/>
             </a:pPr>
             <a:r>
-              <a:rPr lang="en-US" sz="2200" b="1" dirty="0">
+              <a:rPr lang="en-US" sz="2000" b="1" dirty="0">
                 <a:solidFill>
                   <a:schemeClr val="accent1"/>
                 </a:solidFill>
               </a:rPr>
-              <a:t>Future scope</a:t>
-            </a:r>
-            <a:endParaRPr lang="en-US" sz="2200" dirty="0"/>
-          </a:p>
-        </p:txBody>
-      </p:sp>
-      <p:sp>
-        <p:nvSpPr>
-          <p:cNvPr id="8" name="Text 6"/>
+              <a:t>Roadmap</a:t>
+            </a:r>
+            <a:endParaRPr lang="en-US" sz="2000" dirty="0"/>
+          </a:p>
+        </p:txBody>
+      </p:sp>
+      <p:sp>
+        <p:nvSpPr>
+          <p:cNvPr id="26" name="Shape 24"/>
+          <p:cNvSpPr/>
+          <p:nvPr/>
+        </p:nvSpPr>
+        <p:spPr>
+          <a:xfrm>
+            <a:off x="6812280" y="2468880"/>
+            <a:ext cx="36576" cy="2852928"/>
+          </a:xfrm>
+          <a:prstGeom prst="rect">
+            <a:avLst/>
+          </a:prstGeom>
+          <a:solidFill>
+            <a:srgbClr val="B9D8D2"/>
+          </a:solidFill>
+          <a:ln w="12700">
+            <a:solidFill>
+              <a:srgbClr val="B9D8D2"/>
+            </a:solidFill>
+            <a:prstDash val="solid"/>
+          </a:ln>
+        </p:spPr>
+      </p:sp>
+      <p:sp>
+        <p:nvSpPr>
+          <p:cNvPr id="27" name="Shape 25"/>
+          <p:cNvSpPr/>
+          <p:nvPr/>
+        </p:nvSpPr>
+        <p:spPr>
+          <a:xfrm>
+            <a:off x="6601968" y="2240280"/>
+            <a:ext cx="457200" cy="457200"/>
+          </a:xfrm>
+          <a:prstGeom prst="ellipse">
+            <a:avLst/>
+          </a:prstGeom>
+          <a:solidFill>
+            <a:schemeClr val="accent1"/>
+          </a:solidFill>
+          <a:ln w="12700">
+            <a:solidFill>
+              <a:schemeClr val="accent1"/>
+            </a:solidFill>
+            <a:prstDash val="solid"/>
+          </a:ln>
+        </p:spPr>
+      </p:sp>
+      <p:pic>
+        <p:nvPicPr>
+          <p:cNvPr id="28" name="Image 0" descr="Landmark">    </p:cNvPr>
+          <p:cNvPicPr>
+            <a:picLocks noChangeAspect="1"/>
+          </p:cNvPicPr>
+          <p:nvPr/>
+        </p:nvPicPr>
+        <p:blipFill>
+          <a:blip r:embed="rId1"/>
+          <a:stretch>
+            <a:fillRect/>
+          </a:stretch>
+        </p:blipFill>
+        <p:spPr>
+          <a:xfrm>
+            <a:off x="6716268" y="2354580"/>
+            <a:ext cx="228600" cy="228600"/>
+          </a:xfrm>
+          <a:prstGeom prst="rect">
+            <a:avLst/>
+          </a:prstGeom>
+        </p:spPr>
+      </p:pic>
+      <p:sp>
+        <p:nvSpPr>
+          <p:cNvPr id="29" name="Text 26"/>
           <p:cNvSpPr txBox="1"/>
           <p:nvPr/>
         </p:nvSpPr>
         <p:spPr>
           <a:xfrm>
-            <a:off x="6553048" y="2194560"/>
-            <a:ext cx="4815688" cy="3749040"/>
+            <a:off x="7269480" y="2194560"/>
+            <a:ext cx="4099255" cy="566928"/>
           </a:xfrm>
           <a:prstGeom prst="rect">
             <a:avLst/>
@@ -8313,97 +9543,483 @@
           <a:ln/>
         </p:spPr>
         <p:txBody>
-          <a:bodyPr wrap="square" lIns="635" tIns="635" rIns="635" bIns="635" rtlCol="0" anchor="t"/>
-          <a:lstStyle/>
-          <a:p>
-            <a:pPr marL="177800" indent="-177800">
-              <a:spcAft>
-                <a:spcPts val="1200"/>
-              </a:spcAft>
-              <a:buSzPct val="100000"/>
-              <a:buChar char="•"/>
-            </a:pPr>
-            <a:r>
-              <a:rPr lang="en-US" sz="1700" dirty="0">
+          <a:bodyPr wrap="square" lIns="0" tIns="0" rIns="0" bIns="0" rtlCol="0" anchor="ctr"/>
+          <a:lstStyle/>
+          <a:p>
+            <a:pPr indent="0" marL="0">
+              <a:buNone/>
+            </a:pPr>
+            <a:r>
+              <a:rPr lang="en-US" sz="1400" dirty="0">
                 <a:solidFill>
                   <a:schemeClr val="tx1"/>
                 </a:solidFill>
               </a:rPr>
               <a:t>Pilot with one Sub-Registrar office on a sandbox registry feed</a:t>
             </a:r>
-            <a:endParaRPr lang="en-US" sz="1700" dirty="0"/>
-          </a:p>
-          <a:p>
-            <a:pPr marL="177800" indent="-177800">
-              <a:spcAft>
-                <a:spcPts val="1200"/>
-              </a:spcAft>
-              <a:buSzPct val="100000"/>
-              <a:buChar char="•"/>
-            </a:pPr>
-            <a:r>
-              <a:rPr lang="en-US" sz="1700" dirty="0">
+            <a:endParaRPr lang="en-US" sz="1400" dirty="0"/>
+          </a:p>
+        </p:txBody>
+      </p:sp>
+      <p:sp>
+        <p:nvSpPr>
+          <p:cNvPr id="30" name="Shape 27"/>
+          <p:cNvSpPr/>
+          <p:nvPr/>
+        </p:nvSpPr>
+        <p:spPr>
+          <a:xfrm>
+            <a:off x="6601968" y="2953512"/>
+            <a:ext cx="457200" cy="457200"/>
+          </a:xfrm>
+          <a:prstGeom prst="ellipse">
+            <a:avLst/>
+          </a:prstGeom>
+          <a:solidFill>
+            <a:schemeClr val="accent1"/>
+          </a:solidFill>
+          <a:ln w="12700">
+            <a:solidFill>
+              <a:schemeClr val="accent1"/>
+            </a:solidFill>
+            <a:prstDash val="solid"/>
+          </a:ln>
+        </p:spPr>
+      </p:sp>
+      <p:pic>
+        <p:nvPicPr>
+          <p:cNvPr id="31" name="Image 1" descr="Server">    </p:cNvPr>
+          <p:cNvPicPr>
+            <a:picLocks noChangeAspect="1"/>
+          </p:cNvPicPr>
+          <p:nvPr/>
+        </p:nvPicPr>
+        <p:blipFill>
+          <a:blip r:embed="rId2"/>
+          <a:stretch>
+            <a:fillRect/>
+          </a:stretch>
+        </p:blipFill>
+        <p:spPr>
+          <a:xfrm>
+            <a:off x="6716268" y="3067812"/>
+            <a:ext cx="228600" cy="228600"/>
+          </a:xfrm>
+          <a:prstGeom prst="rect">
+            <a:avLst/>
+          </a:prstGeom>
+        </p:spPr>
+      </p:pic>
+      <p:sp>
+        <p:nvSpPr>
+          <p:cNvPr id="32" name="Text 28"/>
+          <p:cNvSpPr txBox="1"/>
+          <p:nvPr/>
+        </p:nvSpPr>
+        <p:spPr>
+          <a:xfrm>
+            <a:off x="7269480" y="2907792"/>
+            <a:ext cx="4099255" cy="566928"/>
+          </a:xfrm>
+          <a:prstGeom prst="rect">
+            <a:avLst/>
+          </a:prstGeom>
+          <a:noFill/>
+          <a:ln/>
+        </p:spPr>
+        <p:txBody>
+          <a:bodyPr wrap="square" lIns="0" tIns="0" rIns="0" bIns="0" rtlCol="0" anchor="ctr"/>
+          <a:lstStyle/>
+          <a:p>
+            <a:pPr indent="0" marL="0">
+              <a:buNone/>
+            </a:pPr>
+            <a:r>
+              <a:rPr lang="en-US" sz="1400" dirty="0">
                 <a:solidFill>
                   <a:schemeClr val="tx1"/>
                 </a:solidFill>
               </a:rPr>
               <a:t>Self-hosted Indic vision model, so documents never leave the department</a:t>
             </a:r>
-            <a:endParaRPr lang="en-US" sz="1700" dirty="0"/>
-          </a:p>
-          <a:p>
-            <a:pPr marL="177800" indent="-177800">
-              <a:spcAft>
-                <a:spcPts val="1200"/>
-              </a:spcAft>
-              <a:buSzPct val="100000"/>
-              <a:buChar char="•"/>
-            </a:pPr>
-            <a:r>
-              <a:rPr lang="en-US" sz="1700" dirty="0">
+            <a:endParaRPr lang="en-US" sz="1400" dirty="0"/>
+          </a:p>
+        </p:txBody>
+      </p:sp>
+      <p:sp>
+        <p:nvSpPr>
+          <p:cNvPr id="33" name="Shape 29"/>
+          <p:cNvSpPr/>
+          <p:nvPr/>
+        </p:nvSpPr>
+        <p:spPr>
+          <a:xfrm>
+            <a:off x="6601968" y="3666744"/>
+            <a:ext cx="457200" cy="457200"/>
+          </a:xfrm>
+          <a:prstGeom prst="ellipse">
+            <a:avLst/>
+          </a:prstGeom>
+          <a:solidFill>
+            <a:schemeClr val="accent2"/>
+          </a:solidFill>
+          <a:ln w="12700">
+            <a:solidFill>
+              <a:schemeClr val="accent2"/>
+            </a:solidFill>
+            <a:prstDash val="solid"/>
+          </a:ln>
+        </p:spPr>
+      </p:sp>
+      <p:pic>
+        <p:nvPicPr>
+          <p:cNvPr id="34" name="Image 2" descr="Map">    </p:cNvPr>
+          <p:cNvPicPr>
+            <a:picLocks noChangeAspect="1"/>
+          </p:cNvPicPr>
+          <p:nvPr/>
+        </p:nvPicPr>
+        <p:blipFill>
+          <a:blip r:embed="rId3"/>
+          <a:stretch>
+            <a:fillRect/>
+          </a:stretch>
+        </p:blipFill>
+        <p:spPr>
+          <a:xfrm>
+            <a:off x="6716268" y="3781044"/>
+            <a:ext cx="228600" cy="228600"/>
+          </a:xfrm>
+          <a:prstGeom prst="rect">
+            <a:avLst/>
+          </a:prstGeom>
+        </p:spPr>
+      </p:pic>
+      <p:sp>
+        <p:nvSpPr>
+          <p:cNvPr id="35" name="Text 30"/>
+          <p:cNvSpPr txBox="1"/>
+          <p:nvPr/>
+        </p:nvSpPr>
+        <p:spPr>
+          <a:xfrm>
+            <a:off x="7269480" y="3621024"/>
+            <a:ext cx="4099255" cy="566928"/>
+          </a:xfrm>
+          <a:prstGeom prst="rect">
+            <a:avLst/>
+          </a:prstGeom>
+          <a:noFill/>
+          <a:ln/>
+        </p:spPr>
+        <p:txBody>
+          <a:bodyPr wrap="square" lIns="0" tIns="0" rIns="0" bIns="0" rtlCol="0" anchor="ctr"/>
+          <a:lstStyle/>
+          <a:p>
+            <a:pPr indent="0" marL="0">
+              <a:buNone/>
+            </a:pPr>
+            <a:r>
+              <a:rPr lang="en-US" sz="1400" dirty="0">
                 <a:solidFill>
                   <a:schemeClr val="tx1"/>
                 </a:solidFill>
               </a:rPr>
-              <a:t>State-specific rule packs and an Indic handwriting test set from consented specimens</a:t>
-            </a:r>
-            <a:endParaRPr lang="en-US" sz="1700" dirty="0"/>
-          </a:p>
-          <a:p>
-            <a:pPr marL="177800" indent="-177800">
-              <a:spcAft>
-                <a:spcPts val="1200"/>
-              </a:spcAft>
-              <a:buSzPct val="100000"/>
-              <a:buChar char="•"/>
-            </a:pPr>
-            <a:r>
-              <a:rPr lang="en-US" sz="1700" dirty="0">
+              <a:t>State rule packs and a real Indic handwriting test set from consented specimens</a:t>
+            </a:r>
+            <a:endParaRPr lang="en-US" sz="1400" dirty="0"/>
+          </a:p>
+        </p:txBody>
+      </p:sp>
+      <p:sp>
+        <p:nvSpPr>
+          <p:cNvPr id="36" name="Shape 31"/>
+          <p:cNvSpPr/>
+          <p:nvPr/>
+        </p:nvSpPr>
+        <p:spPr>
+          <a:xfrm>
+            <a:off x="6601968" y="4379976"/>
+            <a:ext cx="457200" cy="457200"/>
+          </a:xfrm>
+          <a:prstGeom prst="ellipse">
+            <a:avLst/>
+          </a:prstGeom>
+          <a:solidFill>
+            <a:schemeClr val="accent2"/>
+          </a:solidFill>
+          <a:ln w="12700">
+            <a:solidFill>
+              <a:schemeClr val="accent2"/>
+            </a:solidFill>
+            <a:prstDash val="solid"/>
+          </a:ln>
+        </p:spPr>
+      </p:sp>
+      <p:pic>
+        <p:nvPicPr>
+          <p:cNvPr id="37" name="Image 3" descr="Language">    </p:cNvPr>
+          <p:cNvPicPr>
+            <a:picLocks noChangeAspect="1"/>
+          </p:cNvPicPr>
+          <p:nvPr/>
+        </p:nvPicPr>
+        <p:blipFill>
+          <a:blip r:embed="rId4"/>
+          <a:stretch>
+            <a:fillRect/>
+          </a:stretch>
+        </p:blipFill>
+        <p:spPr>
+          <a:xfrm>
+            <a:off x="6716268" y="4494276"/>
+            <a:ext cx="228600" cy="228600"/>
+          </a:xfrm>
+          <a:prstGeom prst="rect">
+            <a:avLst/>
+          </a:prstGeom>
+        </p:spPr>
+      </p:pic>
+      <p:sp>
+        <p:nvSpPr>
+          <p:cNvPr id="38" name="Text 32"/>
+          <p:cNvSpPr txBox="1"/>
+          <p:nvPr/>
+        </p:nvSpPr>
+        <p:spPr>
+          <a:xfrm>
+            <a:off x="7269480" y="4334256"/>
+            <a:ext cx="4099255" cy="566928"/>
+          </a:xfrm>
+          <a:prstGeom prst="rect">
+            <a:avLst/>
+          </a:prstGeom>
+          <a:noFill/>
+          <a:ln/>
+        </p:spPr>
+        <p:txBody>
+          <a:bodyPr wrap="square" lIns="0" tIns="0" rIns="0" bIns="0" rtlCol="0" anchor="ctr"/>
+          <a:lstStyle/>
+          <a:p>
+            <a:pPr indent="0" marL="0">
+              <a:buNone/>
+            </a:pPr>
+            <a:r>
+              <a:rPr lang="en-US" sz="1400" dirty="0">
                 <a:solidFill>
                   <a:schemeClr val="tx1"/>
                 </a:solidFill>
               </a:rPr>
               <a:t>Transliteration-aware name matching across scripts</a:t>
             </a:r>
-            <a:endParaRPr lang="en-US" sz="1700" dirty="0"/>
-          </a:p>
-          <a:p>
-            <a:pPr marL="177800" indent="-177800">
-              <a:spcAft>
-                <a:spcPts val="1200"/>
-              </a:spcAft>
-              <a:buSzPct val="100000"/>
-              <a:buChar char="•"/>
-            </a:pPr>
-            <a:r>
-              <a:rPr lang="en-US" sz="1700" dirty="0">
+            <a:endParaRPr lang="en-US" sz="1400" dirty="0"/>
+          </a:p>
+        </p:txBody>
+      </p:sp>
+      <p:sp>
+        <p:nvSpPr>
+          <p:cNvPr id="39" name="Shape 33"/>
+          <p:cNvSpPr/>
+          <p:nvPr/>
+        </p:nvSpPr>
+        <p:spPr>
+          <a:xfrm>
+            <a:off x="6601968" y="5093208"/>
+            <a:ext cx="457200" cy="457200"/>
+          </a:xfrm>
+          <a:prstGeom prst="ellipse">
+            <a:avLst/>
+          </a:prstGeom>
+          <a:solidFill>
+            <a:schemeClr val="accent2"/>
+          </a:solidFill>
+          <a:ln w="12700">
+            <a:solidFill>
+              <a:schemeClr val="accent2"/>
+            </a:solidFill>
+            <a:prstDash val="solid"/>
+          </a:ln>
+        </p:spPr>
+      </p:sp>
+      <p:pic>
+        <p:nvPicPr>
+          <p:cNvPr id="40" name="Image 4" descr="Robot">    </p:cNvPr>
+          <p:cNvPicPr>
+            <a:picLocks noChangeAspect="1"/>
+          </p:cNvPicPr>
+          <p:nvPr/>
+        </p:nvPicPr>
+        <p:blipFill>
+          <a:blip r:embed="rId5"/>
+          <a:stretch>
+            <a:fillRect/>
+          </a:stretch>
+        </p:blipFill>
+        <p:spPr>
+          <a:xfrm>
+            <a:off x="6716268" y="5207508"/>
+            <a:ext cx="228600" cy="228600"/>
+          </a:xfrm>
+          <a:prstGeom prst="rect">
+            <a:avLst/>
+          </a:prstGeom>
+        </p:spPr>
+      </p:pic>
+      <p:sp>
+        <p:nvSpPr>
+          <p:cNvPr id="41" name="Text 34"/>
+          <p:cNvSpPr txBox="1"/>
+          <p:nvPr/>
+        </p:nvSpPr>
+        <p:spPr>
+          <a:xfrm>
+            <a:off x="7269480" y="5047488"/>
+            <a:ext cx="4099255" cy="566928"/>
+          </a:xfrm>
+          <a:prstGeom prst="rect">
+            <a:avLst/>
+          </a:prstGeom>
+          <a:noFill/>
+          <a:ln/>
+        </p:spPr>
+        <p:txBody>
+          <a:bodyPr wrap="square" lIns="0" tIns="0" rIns="0" bIns="0" rtlCol="0" anchor="ctr"/>
+          <a:lstStyle/>
+          <a:p>
+            <a:pPr indent="0" marL="0">
+              <a:buNone/>
+            </a:pPr>
+            <a:r>
+              <a:rPr lang="en-US" sz="1400" dirty="0">
                 <a:solidFill>
                   <a:schemeClr val="tx1"/>
                 </a:solidFill>
               </a:rPr>
-              <a:t>A Cline-powered assistant that answers “why was this flagged?” from the evidence</a:t>
-            </a:r>
-            <a:endParaRPr lang="en-US" sz="1700" dirty="0"/>
+              <a:t>A Cline-powered assistant that answers “why was this flagged?”</a:t>
+            </a:r>
+            <a:endParaRPr lang="en-US" sz="1400" dirty="0"/>
+          </a:p>
+        </p:txBody>
+      </p:sp>
+      <p:sp>
+        <p:nvSpPr>
+          <p:cNvPr id="42" name="Shape 35"/>
+          <p:cNvSpPr/>
+          <p:nvPr/>
+        </p:nvSpPr>
+        <p:spPr>
+          <a:xfrm>
+            <a:off x="6629400" y="5669280"/>
+            <a:ext cx="164592" cy="164592"/>
+          </a:xfrm>
+          <a:prstGeom prst="ellipse">
+            <a:avLst/>
+          </a:prstGeom>
+          <a:solidFill>
+            <a:schemeClr val="accent1"/>
+          </a:solidFill>
+          <a:ln w="12700">
+            <a:solidFill>
+              <a:schemeClr val="accent1"/>
+            </a:solidFill>
+            <a:prstDash val="solid"/>
+          </a:ln>
+        </p:spPr>
+      </p:sp>
+      <p:sp>
+        <p:nvSpPr>
+          <p:cNvPr id="43" name="Text 36"/>
+          <p:cNvSpPr txBox="1"/>
+          <p:nvPr/>
+        </p:nvSpPr>
+        <p:spPr>
+          <a:xfrm>
+            <a:off x="6858000" y="5596128"/>
+            <a:ext cx="822960" cy="310896"/>
+          </a:xfrm>
+          <a:prstGeom prst="rect">
+            <a:avLst/>
+          </a:prstGeom>
+          <a:noFill/>
+          <a:ln/>
+        </p:spPr>
+        <p:txBody>
+          <a:bodyPr wrap="square" lIns="0" tIns="0" rIns="0" bIns="0" rtlCol="0" anchor="ctr"/>
+          <a:lstStyle/>
+          <a:p>
+            <a:pPr indent="0" marL="0">
+              <a:buNone/>
+            </a:pPr>
+            <a:r>
+              <a:rPr lang="en-US" sz="1200" dirty="0">
+                <a:solidFill>
+                  <a:srgbClr val="5B7276"/>
+                </a:solidFill>
+              </a:rPr>
+              <a:t>Next</a:t>
+            </a:r>
+            <a:endParaRPr lang="en-US" sz="1200" dirty="0"/>
+          </a:p>
+        </p:txBody>
+      </p:sp>
+      <p:sp>
+        <p:nvSpPr>
+          <p:cNvPr id="44" name="Shape 37"/>
+          <p:cNvSpPr/>
+          <p:nvPr/>
+        </p:nvSpPr>
+        <p:spPr>
+          <a:xfrm>
+            <a:off x="7680960" y="5669280"/>
+            <a:ext cx="164592" cy="164592"/>
+          </a:xfrm>
+          <a:prstGeom prst="ellipse">
+            <a:avLst/>
+          </a:prstGeom>
+          <a:solidFill>
+            <a:schemeClr val="accent2"/>
+          </a:solidFill>
+          <a:ln w="12700">
+            <a:solidFill>
+              <a:schemeClr val="accent2"/>
+            </a:solidFill>
+            <a:prstDash val="solid"/>
+          </a:ln>
+        </p:spPr>
+      </p:sp>
+      <p:sp>
+        <p:nvSpPr>
+          <p:cNvPr id="45" name="Text 38"/>
+          <p:cNvSpPr txBox="1"/>
+          <p:nvPr/>
+        </p:nvSpPr>
+        <p:spPr>
+          <a:xfrm>
+            <a:off x="7909560" y="5596128"/>
+            <a:ext cx="822960" cy="310896"/>
+          </a:xfrm>
+          <a:prstGeom prst="rect">
+            <a:avLst/>
+          </a:prstGeom>
+          <a:noFill/>
+          <a:ln/>
+        </p:spPr>
+        <p:txBody>
+          <a:bodyPr wrap="square" lIns="0" tIns="0" rIns="0" bIns="0" rtlCol="0" anchor="ctr"/>
+          <a:lstStyle/>
+          <a:p>
+            <a:pPr indent="0" marL="0">
+              <a:buNone/>
+            </a:pPr>
+            <a:r>
+              <a:rPr lang="en-US" sz="1200" dirty="0">
+                <a:solidFill>
+                  <a:srgbClr val="5B7276"/>
+                </a:solidFill>
+              </a:rPr>
+              <a:t>Later</a:t>
+            </a:r>
+            <a:endParaRPr lang="en-US" sz="1200" dirty="0"/>
           </a:p>
         </p:txBody>
       </p:sp>

</xml_diff>